<commit_message>
fix: keep the multilingual glossary out of English answers
</commit_message>
<xml_diff>
--- a/deck/DengueSUX_Round1.pptx
+++ b/deck/DengueSUX_Round1.pptx
@@ -4,14 +4,14 @@
   <p:sldMasterIdLst>
     <p:sldMasterId id="2147483648" r:id="rId1"/>
   </p:sldMasterIdLst>
+  <p:notesMasterIdLst>
+    <p:notesMasterId r:id="rId5"/>
+  </p:notesMasterIdLst>
   <p:sldIdLst>
     <p:sldId id="256" r:id="rId2"/>
     <p:sldId id="257" r:id="rId3"/>
     <p:sldId id="258" r:id="rId4"/>
   </p:sldIdLst>
-  <p:notesMasterIdLst>
-    <p:notesMasterId r:id="rId5"/>
-  </p:notesMasterIdLst>
   <p:sldSz cx="12192000" cy="6858000"/>
   <p:notesSz cx="6858000" cy="12192000"/>
   <p:defaultTextStyle>
@@ -106,13 +106,20 @@
       </a:defRPr>
     </a:lvl9pPr>
   </p:defaultTextStyle>
+  <p:extLst>
+    <p:ext uri="{EFAFB233-063F-42B5-8137-9DF3F51BA10A}">
+      <p15:sldGuideLst xmlns:p15="http://schemas.microsoft.com/office/powerpoint/2012/main"/>
+    </p:ext>
+  </p:extLst>
 </p:presentation>
 </file>
 
 <file path=ppt/charts/chart1.xml><?xml version="1.0" encoding="utf-8"?>
-<c:chartSpace xmlns:c="http://schemas.openxmlformats.org/drawingml/2006/chart" xmlns:a="http://schemas.openxmlformats.org/drawingml/2006/main" xmlns:r="http://schemas.openxmlformats.org/officeDocument/2006/relationships">
+<c:chartSpace xmlns:c="http://schemas.openxmlformats.org/drawingml/2006/chart" xmlns:a="http://schemas.openxmlformats.org/drawingml/2006/main" xmlns:r="http://schemas.openxmlformats.org/officeDocument/2006/relationships" xmlns:c16r2="http://schemas.microsoft.com/office/drawing/2015/06/chart">
   <c:date1904 val="0"/>
+  <c:lang val="en-GB"/>
   <c:roundedCorners val="1"/>
+  <c:style val="2"/>
   <c:chart>
     <c:autoTitleDeleted val="1"/>
     <c:plotArea>
@@ -142,72 +149,46 @@
             <a:effectLst/>
           </c:spPr>
           <c:invertIfNegative val="0"/>
-          <c:dLbls>
-            <c:numFmt formatCode="#,##0" sourceLinked="0"/>
-            <c:txPr>
-              <a:bodyPr/>
-              <a:lstStyle/>
-              <a:p>
-                <a:pPr>
-                  <a:defRPr b="0" i="0" strike="noStrike" sz="1200" u="none">
-                    <a:solidFill>
-                      <a:srgbClr val="000000"/>
-                    </a:solidFill>
-                    <a:latin typeface="Arial"/>
-                  </a:defRPr>
-                </a:pPr>
-              </a:p>
-            </c:txPr>
-            <c:showLegendKey val="0"/>
-            <c:showVal val="0"/>
-            <c:showCatName val="0"/>
-            <c:showSerName val="0"/>
-            <c:showPercent val="0"/>
-            <c:showBubbleSize val="0"/>
-            <c:showLeaderLines val="0"/>
-          </c:dLbls>
           <c:cat>
-            <c:multiLvlStrRef>
+            <c:strRef>
               <c:f>Sheet1!$A$2:$A$12</c:f>
-              <c:multiLvlStrCache>
+              <c:strCache>
                 <c:ptCount val="11"/>
-                <c:lvl>
-                  <c:pt idx="0">
-                    <c:v>2012</c:v>
-                  </c:pt>
-                  <c:pt idx="1">
-                    <c:v>2013</c:v>
-                  </c:pt>
-                  <c:pt idx="2">
-                    <c:v>2014</c:v>
-                  </c:pt>
-                  <c:pt idx="3">
-                    <c:v>2015</c:v>
-                  </c:pt>
-                  <c:pt idx="4">
-                    <c:v>2016</c:v>
-                  </c:pt>
-                  <c:pt idx="5">
-                    <c:v>2017</c:v>
-                  </c:pt>
-                  <c:pt idx="6">
-                    <c:v>2018</c:v>
-                  </c:pt>
-                  <c:pt idx="7">
-                    <c:v>2019</c:v>
-                  </c:pt>
-                  <c:pt idx="8">
-                    <c:v>2020</c:v>
-                  </c:pt>
-                  <c:pt idx="9">
-                    <c:v>2021</c:v>
-                  </c:pt>
-                  <c:pt idx="10">
-                    <c:v>2022</c:v>
-                  </c:pt>
-                </c:lvl>
-              </c:multiLvlStrCache>
-            </c:multiLvlStrRef>
+                <c:pt idx="0">
+                  <c:v>2012</c:v>
+                </c:pt>
+                <c:pt idx="1">
+                  <c:v>2013</c:v>
+                </c:pt>
+                <c:pt idx="2">
+                  <c:v>2014</c:v>
+                </c:pt>
+                <c:pt idx="3">
+                  <c:v>2015</c:v>
+                </c:pt>
+                <c:pt idx="4">
+                  <c:v>2016</c:v>
+                </c:pt>
+                <c:pt idx="5">
+                  <c:v>2017</c:v>
+                </c:pt>
+                <c:pt idx="6">
+                  <c:v>2018</c:v>
+                </c:pt>
+                <c:pt idx="7">
+                  <c:v>2019</c:v>
+                </c:pt>
+                <c:pt idx="8">
+                  <c:v>2020</c:v>
+                </c:pt>
+                <c:pt idx="9">
+                  <c:v>2021</c:v>
+                </c:pt>
+                <c:pt idx="10">
+                  <c:v>2022</c:v>
+                </c:pt>
+              </c:strCache>
+            </c:strRef>
           </c:cat>
           <c:val>
             <c:numRef>
@@ -251,6 +232,11 @@
               </c:numCache>
             </c:numRef>
           </c:val>
+          <c:extLst>
+            <c:ext xmlns:c16="http://schemas.microsoft.com/office/drawing/2014/chart" uri="{C3380CC4-5D6E-409C-BE32-E72D297353CC}">
+              <c16:uniqueId val="{00000000-7116-954E-8BBA-05BF81998C84}"/>
+            </c:ext>
+          </c:extLst>
         </c:ser>
         <c:ser>
           <c:idx val="1"/>
@@ -273,72 +259,46 @@
             <a:effectLst/>
           </c:spPr>
           <c:invertIfNegative val="0"/>
-          <c:dLbls>
-            <c:numFmt formatCode="#,##0" sourceLinked="0"/>
-            <c:txPr>
-              <a:bodyPr/>
-              <a:lstStyle/>
-              <a:p>
-                <a:pPr>
-                  <a:defRPr b="0" i="0" strike="noStrike" sz="1200" u="none">
-                    <a:solidFill>
-                      <a:srgbClr val="000000"/>
-                    </a:solidFill>
-                    <a:latin typeface="Arial"/>
-                  </a:defRPr>
-                </a:pPr>
-              </a:p>
-            </c:txPr>
-            <c:showLegendKey val="0"/>
-            <c:showVal val="0"/>
-            <c:showCatName val="0"/>
-            <c:showSerName val="0"/>
-            <c:showPercent val="0"/>
-            <c:showBubbleSize val="0"/>
-            <c:showLeaderLines val="0"/>
-          </c:dLbls>
           <c:cat>
-            <c:multiLvlStrRef>
+            <c:strRef>
               <c:f>Sheet1!$A$2:$A$12</c:f>
-              <c:multiLvlStrCache>
+              <c:strCache>
                 <c:ptCount val="11"/>
-                <c:lvl>
-                  <c:pt idx="0">
-                    <c:v>2012</c:v>
-                  </c:pt>
-                  <c:pt idx="1">
-                    <c:v>2013</c:v>
-                  </c:pt>
-                  <c:pt idx="2">
-                    <c:v>2014</c:v>
-                  </c:pt>
-                  <c:pt idx="3">
-                    <c:v>2015</c:v>
-                  </c:pt>
-                  <c:pt idx="4">
-                    <c:v>2016</c:v>
-                  </c:pt>
-                  <c:pt idx="5">
-                    <c:v>2017</c:v>
-                  </c:pt>
-                  <c:pt idx="6">
-                    <c:v>2018</c:v>
-                  </c:pt>
-                  <c:pt idx="7">
-                    <c:v>2019</c:v>
-                  </c:pt>
-                  <c:pt idx="8">
-                    <c:v>2020</c:v>
-                  </c:pt>
-                  <c:pt idx="9">
-                    <c:v>2021</c:v>
-                  </c:pt>
-                  <c:pt idx="10">
-                    <c:v>2022</c:v>
-                  </c:pt>
-                </c:lvl>
-              </c:multiLvlStrCache>
-            </c:multiLvlStrRef>
+                <c:pt idx="0">
+                  <c:v>2012</c:v>
+                </c:pt>
+                <c:pt idx="1">
+                  <c:v>2013</c:v>
+                </c:pt>
+                <c:pt idx="2">
+                  <c:v>2014</c:v>
+                </c:pt>
+                <c:pt idx="3">
+                  <c:v>2015</c:v>
+                </c:pt>
+                <c:pt idx="4">
+                  <c:v>2016</c:v>
+                </c:pt>
+                <c:pt idx="5">
+                  <c:v>2017</c:v>
+                </c:pt>
+                <c:pt idx="6">
+                  <c:v>2018</c:v>
+                </c:pt>
+                <c:pt idx="7">
+                  <c:v>2019</c:v>
+                </c:pt>
+                <c:pt idx="8">
+                  <c:v>2020</c:v>
+                </c:pt>
+                <c:pt idx="9">
+                  <c:v>2021</c:v>
+                </c:pt>
+                <c:pt idx="10">
+                  <c:v>2022</c:v>
+                </c:pt>
+              </c:strCache>
+            </c:strRef>
           </c:cat>
           <c:val>
             <c:numRef>
@@ -382,36 +342,24 @@
               </c:numCache>
             </c:numRef>
           </c:val>
+          <c:extLst>
+            <c:ext xmlns:c16="http://schemas.microsoft.com/office/drawing/2014/chart" uri="{C3380CC4-5D6E-409C-BE32-E72D297353CC}">
+              <c16:uniqueId val="{00000001-7116-954E-8BBA-05BF81998C84}"/>
+            </c:ext>
+          </c:extLst>
         </c:ser>
         <c:dLbls>
-          <c:numFmt formatCode="#,##0" sourceLinked="0"/>
-          <c:txPr>
-            <a:bodyPr/>
-            <a:lstStyle/>
-            <a:p>
-              <a:pPr>
-                <a:defRPr b="0" i="0" strike="noStrike" sz="1200" u="none">
-                  <a:solidFill>
-                    <a:srgbClr val="000000"/>
-                  </a:solidFill>
-                  <a:latin typeface="Arial"/>
-                </a:defRPr>
-              </a:pPr>
-            </a:p>
-          </c:txPr>
           <c:showLegendKey val="0"/>
           <c:showVal val="0"/>
           <c:showCatName val="0"/>
           <c:showSerName val="0"/>
           <c:showPercent val="0"/>
           <c:showBubbleSize val="0"/>
-          <c:showLeaderLines val="0"/>
         </c:dLbls>
         <c:gapWidth val="45"/>
         <c:overlap val="100"/>
         <c:axId val="2094734554"/>
         <c:axId val="2094734552"/>
-        <c:axId val="2094734556"/>
       </c:barChart>
       <c:catAx>
         <c:axId val="2094734554"/>
@@ -450,6 +398,7 @@
         <c:crosses val="autoZero"/>
         <c:auto val="1"/>
         <c:lblAlgn val="ctr"/>
+        <c:lblOffset val="100"/>
         <c:noMultiLvlLbl val="1"/>
       </c:catAx>
       <c:valAx>
@@ -512,6 +461,7 @@
     </c:plotArea>
     <c:plotVisOnly val="1"/>
     <c:dispBlanksAs val="span"/>
+    <c:showDLblsOverMax val="1"/>
   </c:chart>
   <c:spPr>
     <a:noFill/>
@@ -548,234 +498,10 @@
           <a:chExt cx="0" cy="0"/>
         </a:xfrm>
       </p:grpSpPr>
-      <p:sp>
-        <p:nvSpPr>
-          <p:cNvPr id="2" name="Header Placeholder 1"/>
-          <p:cNvSpPr>
-            <a:spLocks noGrp="1"/>
-          </p:cNvSpPr>
-          <p:nvPr>
-            <p:ph type="hdr" sz="quarter"/>
-          </p:nvPr>
-        </p:nvSpPr>
-        <p:spPr>
-          <a:xfrm>
-            <a:off x="0" y="0"/>
-            <a:ext cx="2971800" cy="458788"/>
-          </a:xfrm>
-          <a:prstGeom prst="rect">
-            <a:avLst/>
-          </a:prstGeom>
-        </p:spPr>
-        <p:txBody>
-          <a:bodyPr vert="horz" lIns="91440" tIns="45720" rIns="91440" bIns="45720" rtlCol="0"/>
-          <a:lstStyle>
-            <a:lvl1pPr algn="l">
-              <a:defRPr sz="1200"/>
-            </a:lvl1pPr>
-          </a:lstStyle>
-          <a:p>
-            <a:endParaRPr lang="en-US"/>
-          </a:p>
-        </p:txBody>
-      </p:sp>
-      <p:sp>
-        <p:nvSpPr>
-          <p:cNvPr id="3" name="Date Placeholder 2"/>
-          <p:cNvSpPr>
-            <a:spLocks noGrp="1"/>
-          </p:cNvSpPr>
-          <p:nvPr>
-            <p:ph type="dt" idx="1"/>
-          </p:nvPr>
-        </p:nvSpPr>
-        <p:spPr>
-          <a:xfrm>
-            <a:off x="3884613" y="0"/>
-            <a:ext cx="2971800" cy="458788"/>
-          </a:xfrm>
-          <a:prstGeom prst="rect">
-            <a:avLst/>
-          </a:prstGeom>
-        </p:spPr>
-        <p:txBody>
-          <a:bodyPr vert="horz" lIns="91440" tIns="45720" rIns="91440" bIns="45720" rtlCol="0"/>
-          <a:lstStyle>
-            <a:lvl1pPr algn="r">
-              <a:defRPr sz="1200"/>
-            </a:lvl1pPr>
-          </a:lstStyle>
-          <a:p>
-            <a:fld id="{5282F153-3F37-0F45-9E97-73ACFA13230C}" type="datetimeFigureOut">
-              <a:rPr lang="en-US"/>
-              <a:t>7/23/19</a:t>
-            </a:fld>
-            <a:endParaRPr lang="en-US"/>
-          </a:p>
-        </p:txBody>
-      </p:sp>
-      <p:sp>
-        <p:nvSpPr>
-          <p:cNvPr id="4" name="Slide Image Placeholder 3"/>
-          <p:cNvSpPr>
-            <a:spLocks noGrp="1" noRot="1" noChangeAspect="1"/>
-          </p:cNvSpPr>
-          <p:nvPr>
-            <p:ph type="sldImg" idx="2"/>
-          </p:nvPr>
-        </p:nvSpPr>
-        <p:spPr>
-          <a:xfrm>
-            <a:off x="685800" y="1143000"/>
-            <a:ext cx="5486400" cy="3086100"/>
-          </a:xfrm>
-          <a:prstGeom prst="rect">
-            <a:avLst/>
-          </a:prstGeom>
-          <a:noFill/>
-          <a:ln w="12700">
-            <a:solidFill>
-              <a:prstClr val="black"/>
-            </a:solidFill>
-          </a:ln>
-        </p:spPr>
-        <p:txBody>
-          <a:bodyPr vert="horz" lIns="91440" tIns="45720" rIns="91440" bIns="45720" rtlCol="0" anchor="ctr"/>
-          <a:lstStyle/>
-          <a:p>
-            <a:endParaRPr lang="en-US"/>
-          </a:p>
-        </p:txBody>
-      </p:sp>
-      <p:sp>
-        <p:nvSpPr>
-          <p:cNvPr id="5" name="Notes Placeholder 4"/>
-          <p:cNvSpPr>
-            <a:spLocks noGrp="1"/>
-          </p:cNvSpPr>
-          <p:nvPr>
-            <p:ph type="body" sz="quarter" idx="3"/>
-          </p:nvPr>
-        </p:nvSpPr>
-        <p:spPr>
-          <a:xfrm>
-            <a:off x="685800" y="4400550"/>
-            <a:ext cx="5486400" cy="3600450"/>
-          </a:xfrm>
-          <a:prstGeom prst="rect">
-            <a:avLst/>
-          </a:prstGeom>
-        </p:spPr>
-        <p:txBody>
-          <a:bodyPr vert="horz" lIns="91440" tIns="45720" rIns="91440" bIns="45720" rtlCol="0"/>
-          <a:lstStyle/>
-          <a:p>
-            <a:pPr lvl="0"/>
-            <a:r>
-              <a:rPr lang="en-US"/>
-              <a:t>Click to edit Master text styles</a:t>
-            </a:r>
-          </a:p>
-          <a:p>
-            <a:pPr lvl="1"/>
-            <a:r>
-              <a:rPr lang="en-US"/>
-              <a:t>Second level</a:t>
-            </a:r>
-          </a:p>
-          <a:p>
-            <a:pPr lvl="2"/>
-            <a:r>
-              <a:rPr lang="en-US"/>
-              <a:t>Third level</a:t>
-            </a:r>
-          </a:p>
-          <a:p>
-            <a:pPr lvl="3"/>
-            <a:r>
-              <a:rPr lang="en-US"/>
-              <a:t>Fourth level</a:t>
-            </a:r>
-          </a:p>
-          <a:p>
-            <a:pPr lvl="4"/>
-            <a:r>
-              <a:rPr lang="en-US"/>
-              <a:t>Fifth level</a:t>
-            </a:r>
-          </a:p>
-        </p:txBody>
-      </p:sp>
-      <p:sp>
-        <p:nvSpPr>
-          <p:cNvPr id="6" name="Footer Placeholder 5"/>
-          <p:cNvSpPr>
-            <a:spLocks noGrp="1"/>
-          </p:cNvSpPr>
-          <p:nvPr>
-            <p:ph type="ftr" sz="quarter" idx="4"/>
-          </p:nvPr>
-        </p:nvSpPr>
-        <p:spPr>
-          <a:xfrm>
-            <a:off x="0" y="8685213"/>
-            <a:ext cx="2971800" cy="458787"/>
-          </a:xfrm>
-          <a:prstGeom prst="rect">
-            <a:avLst/>
-          </a:prstGeom>
-        </p:spPr>
-        <p:txBody>
-          <a:bodyPr vert="horz" lIns="91440" tIns="45720" rIns="91440" bIns="45720" rtlCol="0" anchor="b"/>
-          <a:lstStyle>
-            <a:lvl1pPr algn="l">
-              <a:defRPr sz="1200"/>
-            </a:lvl1pPr>
-          </a:lstStyle>
-          <a:p>
-            <a:endParaRPr lang="en-US"/>
-          </a:p>
-        </p:txBody>
-      </p:sp>
-      <p:sp>
-        <p:nvSpPr>
-          <p:cNvPr id="7" name="Slide Number Placeholder 6"/>
-          <p:cNvSpPr>
-            <a:spLocks noGrp="1"/>
-          </p:cNvSpPr>
-          <p:nvPr>
-            <p:ph type="sldNum" sz="quarter" idx="5"/>
-          </p:nvPr>
-        </p:nvSpPr>
-        <p:spPr>
-          <a:xfrm>
-            <a:off x="3884613" y="8685213"/>
-            <a:ext cx="2971800" cy="458787"/>
-          </a:xfrm>
-          <a:prstGeom prst="rect">
-            <a:avLst/>
-          </a:prstGeom>
-        </p:spPr>
-        <p:txBody>
-          <a:bodyPr vert="horz" lIns="91440" tIns="45720" rIns="91440" bIns="45720" rtlCol="0" anchor="b"/>
-          <a:lstStyle>
-            <a:lvl1pPr algn="r">
-              <a:defRPr sz="1200"/>
-            </a:lvl1pPr>
-          </a:lstStyle>
-          <a:p>
-            <a:fld id="{CE5E9CC1-C706-0F49-92D6-E571CC5EEA8F}" type="slidenum">
-              <a:rPr lang="en-US"/>
-              <a:t>‹#›</a:t>
-            </a:fld>
-            <a:endParaRPr lang="en-US"/>
-          </a:p>
-        </p:txBody>
-      </p:sp>
     </p:spTree>
     <p:extLst>
       <p:ext uri="{BB962C8B-B14F-4D97-AF65-F5344CB8AC3E}">
-        <p14:creationId xmlns:p14="http://schemas.microsoft.com/office/powerpoint/2010/main" val="1024086991"/>
+        <p14:creationId xmlns:p14="http://schemas.microsoft.com/office/powerpoint/2010/main" val="475688898"/>
       </p:ext>
     </p:extLst>
   </p:cSld>
@@ -919,10 +645,6 @@
           <a:bodyPr/>
           <a:lstStyle/>
           <a:p>
-            <a:r>
-              <a:rPr lang="en-US" dirty="0"/>
-              <a:t/>
-            </a:r>
             <a:endParaRPr lang="en-US" dirty="0"/>
           </a:p>
         </p:txBody>
@@ -1007,10 +729,6 @@
           <a:bodyPr/>
           <a:lstStyle/>
           <a:p>
-            <a:r>
-              <a:rPr lang="en-US" dirty="0"/>
-              <a:t/>
-            </a:r>
             <a:endParaRPr lang="en-US" dirty="0"/>
           </a:p>
         </p:txBody>
@@ -1095,10 +813,6 @@
           <a:bodyPr/>
           <a:lstStyle/>
           <a:p>
-            <a:r>
-              <a:rPr lang="en-US" dirty="0"/>
-              <a:t/>
-            </a:r>
             <a:endParaRPr lang="en-US" dirty="0"/>
           </a:p>
         </p:txBody>
@@ -1172,6 +886,11 @@
 <file path=ppt/slideMasters/slideMaster1.xml><?xml version="1.0" encoding="utf-8"?>
 <p:sldMaster xmlns:a="http://schemas.openxmlformats.org/drawingml/2006/main" xmlns:r="http://schemas.openxmlformats.org/officeDocument/2006/relationships" xmlns:p="http://schemas.openxmlformats.org/presentationml/2006/main">
   <p:cSld>
+    <p:bg>
+      <p:bgRef idx="1001">
+        <a:schemeClr val="bg1"/>
+      </p:bgRef>
+    </p:bg>
     <p:spTree>
       <p:nvGrpSpPr>
         <p:cNvPr id="1" name=""/>
@@ -1454,6 +1173,7 @@
         <a:solidFill>
           <a:srgbClr val="FFFFFF"/>
         </a:solidFill>
+        <a:effectLst/>
       </p:bgPr>
     </p:bg>
     <p:spTree>
@@ -1494,6 +1214,13 @@
             <a:prstDash val="solid"/>
           </a:ln>
         </p:spPr>
+        <p:txBody>
+          <a:bodyPr/>
+          <a:lstStyle/>
+          <a:p>
+            <a:endParaRPr lang="en-US"/>
+          </a:p>
+        </p:txBody>
       </p:sp>
       <p:sp>
         <p:nvSpPr>
@@ -1516,7 +1243,7 @@
           <a:bodyPr wrap="square" lIns="0" tIns="0" rIns="0" bIns="0" rtlCol="0" anchor="ctr"/>
           <a:lstStyle/>
           <a:p>
-            <a:pPr indent="0" marL="0">
+            <a:pPr marL="0" indent="0">
               <a:buNone/>
             </a:pPr>
             <a:r>
@@ -1555,7 +1282,7 @@
           <a:bodyPr wrap="square" lIns="0" tIns="0" rIns="0" bIns="0" rtlCol="0" anchor="ctr"/>
           <a:lstStyle/>
           <a:p>
-            <a:pPr indent="0" marL="0">
+            <a:pPr marL="0" indent="0">
               <a:buNone/>
             </a:pPr>
             <a:r>
@@ -1594,7 +1321,7 @@
           <a:bodyPr wrap="square" lIns="0" tIns="0" rIns="0" bIns="0" rtlCol="0" anchor="ctr"/>
           <a:lstStyle/>
           <a:p>
-            <a:pPr indent="0" marL="0">
+            <a:pPr marL="0" indent="0">
               <a:buNone/>
             </a:pPr>
             <a:r>
@@ -1633,11 +1360,11 @@
           <a:bodyPr wrap="square" lIns="0" tIns="0" rIns="0" bIns="0" rtlCol="0" anchor="ctr"/>
           <a:lstStyle/>
           <a:p>
-            <a:pPr indent="0" marL="0">
-              <a:buNone/>
-            </a:pPr>
-            <a:r>
-              <a:rPr lang="en-US" sz="1100" b="1" spc="100" kern="0" dirty="0">
+            <a:pPr marL="0" indent="0">
+              <a:buNone/>
+            </a:pPr>
+            <a:r>
+              <a:rPr lang="en-US" sz="1100" b="1" kern="0" spc="100" dirty="0">
                 <a:solidFill>
                   <a:srgbClr val="FF3621"/>
                 </a:solidFill>
@@ -1647,9 +1374,6 @@
               </a:rPr>
               <a:t>TEAM  </a:t>
             </a:r>
-            <a:pPr indent="0" marL="0">
-              <a:buNone/>
-            </a:pPr>
             <a:r>
               <a:rPr lang="en-US" sz="1400" b="1" dirty="0">
                 <a:solidFill>
@@ -1661,11 +1385,8 @@
               </a:rPr>
               <a:t>DengueSUX</a:t>
             </a:r>
-            <a:pPr indent="0" marL="0">
-              <a:buNone/>
-            </a:pPr>
-            <a:r>
-              <a:rPr lang="en-US" sz="1100" b="1" spc="100" kern="0" dirty="0">
+            <a:r>
+              <a:rPr lang="en-US" sz="1100" b="1" kern="0" spc="100" dirty="0">
                 <a:solidFill>
                   <a:srgbClr val="FF3621"/>
                 </a:solidFill>
@@ -1675,9 +1396,6 @@
               </a:rPr>
               <a:t>      PROBLEM STATEMENT  </a:t>
             </a:r>
-            <a:pPr indent="0" marL="0">
-              <a:buNone/>
-            </a:pPr>
             <a:r>
               <a:rPr lang="en-US" sz="1400" b="1" dirty="0">
                 <a:solidFill>
@@ -1714,14 +1432,14 @@
           <a:bodyPr wrap="square" lIns="0" tIns="0" rIns="0" bIns="0" rtlCol="0" anchor="t"/>
           <a:lstStyle/>
           <a:p>
-            <a:pPr indent="0" marL="0">
+            <a:pPr marL="0" indent="0">
               <a:spcAft>
                 <a:spcPts val="300"/>
               </a:spcAft>
               <a:buNone/>
             </a:pPr>
             <a:r>
-              <a:rPr lang="en-US" sz="1100" b="1" spc="100" kern="0" dirty="0">
+              <a:rPr lang="en-US" sz="1100" b="1" kern="0" spc="100" dirty="0">
                 <a:solidFill>
                   <a:srgbClr val="FF3621"/>
                 </a:solidFill>
@@ -1734,7 +1452,7 @@
             <a:endParaRPr lang="en-US" sz="1100" dirty="0"/>
           </a:p>
           <a:p>
-            <a:pPr indent="0" marL="0">
+            <a:pPr marL="0" indent="0">
               <a:spcAft>
                 <a:spcPts val="300"/>
               </a:spcAft>
@@ -1776,14 +1494,14 @@
           <a:bodyPr wrap="square" lIns="0" tIns="0" rIns="0" bIns="0" rtlCol="0" anchor="t"/>
           <a:lstStyle/>
           <a:p>
-            <a:pPr indent="0" marL="0">
+            <a:pPr marL="0" indent="0">
               <a:spcAft>
                 <a:spcPts val="300"/>
               </a:spcAft>
               <a:buNone/>
             </a:pPr>
             <a:r>
-              <a:rPr lang="en-US" sz="1100" b="1" spc="100" kern="0" dirty="0">
+              <a:rPr lang="en-US" sz="1100" b="1" kern="0" spc="100" dirty="0">
                 <a:solidFill>
                   <a:srgbClr val="FF3621"/>
                 </a:solidFill>
@@ -1796,7 +1514,7 @@
             <a:endParaRPr lang="en-US" sz="1100" dirty="0"/>
           </a:p>
           <a:p>
-            <a:pPr indent="0" marL="0">
+            <a:pPr marL="0" indent="0">
               <a:spcAft>
                 <a:spcPts val="300"/>
               </a:spcAft>
@@ -1813,103 +1531,96 @@
               </a:rPr>
               <a:t>164,447 </a:t>
             </a:r>
-            <a:pPr indent="0" marL="0">
+            <a:r>
+              <a:rPr lang="en-US" sz="1400" dirty="0">
+                <a:solidFill>
+                  <a:srgbClr val="3D4A52"/>
+                </a:solidFill>
+                <a:latin typeface="Arial" pitchFamily="34" charset="0"/>
+                <a:ea typeface="Arial" pitchFamily="34" charset="-122"/>
+                <a:cs typeface="Arial" pitchFamily="34" charset="-120"/>
+              </a:rPr>
+              <a:t>dengue cases in Singapore from 2012–2022, including a record </a:t>
+            </a:r>
+            <a:r>
+              <a:rPr lang="en-US" sz="1400" b="1" dirty="0">
+                <a:solidFill>
+                  <a:srgbClr val="1B3139"/>
+                </a:solidFill>
+                <a:latin typeface="Arial" pitchFamily="34" charset="0"/>
+                <a:ea typeface="Arial" pitchFamily="34" charset="-122"/>
+                <a:cs typeface="Arial" pitchFamily="34" charset="-120"/>
+              </a:rPr>
+              <a:t>35,315 in 2020</a:t>
+            </a:r>
+            <a:r>
+              <a:rPr lang="en-US" sz="1400" b="1" dirty="0">
+                <a:solidFill>
+                  <a:srgbClr val="3D4A52"/>
+                </a:solidFill>
+                <a:latin typeface="Arial" pitchFamily="34" charset="0"/>
+                <a:ea typeface="Arial" pitchFamily="34" charset="-122"/>
+                <a:cs typeface="Arial" pitchFamily="34" charset="-120"/>
+              </a:rPr>
+              <a:t>; </a:t>
+            </a:r>
+            <a:r>
+              <a:rPr lang="en-US" sz="1400" dirty="0">
+                <a:solidFill>
+                  <a:srgbClr val="3D4A52"/>
+                </a:solidFill>
+                <a:latin typeface="Arial" pitchFamily="34" charset="0"/>
+                <a:ea typeface="Arial" pitchFamily="34" charset="-122"/>
+                <a:cs typeface="Arial" pitchFamily="34" charset="-120"/>
+              </a:rPr>
+              <a:t>1,792 in a single week at the peak. Repeat infections carry a higher risk of severe dengue.</a:t>
+            </a:r>
+            <a:endParaRPr lang="en-US" sz="1100" dirty="0"/>
+          </a:p>
+        </p:txBody>
+      </p:sp>
+      <p:sp>
+        <p:nvSpPr>
+          <p:cNvPr id="9" name="Text 7"/>
+          <p:cNvSpPr txBox="1"/>
+          <p:nvPr/>
+        </p:nvSpPr>
+        <p:spPr>
+          <a:xfrm>
+            <a:off x="822960" y="4389120"/>
+            <a:ext cx="5577840" cy="1188720"/>
+          </a:xfrm>
+          <a:prstGeom prst="rect">
+            <a:avLst/>
+          </a:prstGeom>
+          <a:noFill/>
+          <a:ln/>
+        </p:spPr>
+        <p:txBody>
+          <a:bodyPr wrap="square" lIns="0" tIns="0" rIns="0" bIns="0" rtlCol="0" anchor="t"/>
+          <a:lstStyle/>
+          <a:p>
+            <a:pPr marL="0" indent="0">
               <a:spcAft>
                 <a:spcPts val="300"/>
               </a:spcAft>
               <a:buNone/>
             </a:pPr>
             <a:r>
-              <a:rPr lang="en-US" sz="1400" dirty="0">
-                <a:solidFill>
-                  <a:srgbClr val="3D4A52"/>
-                </a:solidFill>
-                <a:latin typeface="Arial" pitchFamily="34" charset="0"/>
-                <a:ea typeface="Arial" pitchFamily="34" charset="-122"/>
-                <a:cs typeface="Arial" pitchFamily="34" charset="-120"/>
-              </a:rPr>
-              <a:t>dengue cases in Singapore from 2012–2022, including a record </a:t>
-            </a:r>
-            <a:pPr indent="0" marL="0">
-              <a:spcAft>
-                <a:spcPts val="300"/>
-              </a:spcAft>
-              <a:buNone/>
-            </a:pPr>
-            <a:r>
-              <a:rPr lang="en-US" sz="1400" b="1" dirty="0">
-                <a:solidFill>
-                  <a:srgbClr val="1B3139"/>
-                </a:solidFill>
-                <a:latin typeface="Arial" pitchFamily="34" charset="0"/>
-                <a:ea typeface="Arial" pitchFamily="34" charset="-122"/>
-                <a:cs typeface="Arial" pitchFamily="34" charset="-120"/>
-              </a:rPr>
-              <a:t>35,315 in 2020</a:t>
-            </a:r>
-            <a:pPr indent="0" marL="0">
-              <a:spcAft>
-                <a:spcPts val="300"/>
-              </a:spcAft>
-              <a:buNone/>
-            </a:pPr>
-            <a:r>
-              <a:rPr lang="en-US" sz="1400" dirty="0">
-                <a:solidFill>
-                  <a:srgbClr val="3D4A52"/>
-                </a:solidFill>
-                <a:latin typeface="Arial" pitchFamily="34" charset="0"/>
-                <a:ea typeface="Arial" pitchFamily="34" charset="-122"/>
-                <a:cs typeface="Arial" pitchFamily="34" charset="-120"/>
-              </a:rPr>
-              <a:t> — 1,792 in a single week at the peak. Repeat infections carry a higher risk of severe dengue.</a:t>
+              <a:rPr lang="en-US" sz="1100" b="1" kern="0" spc="100" dirty="0">
+                <a:solidFill>
+                  <a:srgbClr val="FF3621"/>
+                </a:solidFill>
+                <a:latin typeface="Arial" pitchFamily="34" charset="0"/>
+                <a:ea typeface="Arial" pitchFamily="34" charset="-122"/>
+                <a:cs typeface="Arial" pitchFamily="34" charset="-120"/>
+              </a:rPr>
+              <a:t>WHY IT MATTERS NOW</a:t>
             </a:r>
             <a:endParaRPr lang="en-US" sz="1100" dirty="0"/>
           </a:p>
-        </p:txBody>
-      </p:sp>
-      <p:sp>
-        <p:nvSpPr>
-          <p:cNvPr id="9" name="Text 7"/>
-          <p:cNvSpPr txBox="1"/>
-          <p:nvPr/>
-        </p:nvSpPr>
-        <p:spPr>
-          <a:xfrm>
-            <a:off x="822960" y="4389120"/>
-            <a:ext cx="5577840" cy="1188720"/>
-          </a:xfrm>
-          <a:prstGeom prst="rect">
-            <a:avLst/>
-          </a:prstGeom>
-          <a:noFill/>
-          <a:ln/>
-        </p:spPr>
-        <p:txBody>
-          <a:bodyPr wrap="square" lIns="0" tIns="0" rIns="0" bIns="0" rtlCol="0" anchor="t"/>
-          <a:lstStyle/>
-          <a:p>
-            <a:pPr indent="0" marL="0">
-              <a:spcAft>
-                <a:spcPts val="300"/>
-              </a:spcAft>
-              <a:buNone/>
-            </a:pPr>
-            <a:r>
-              <a:rPr lang="en-US" sz="1100" b="1" spc="100" kern="0" dirty="0">
-                <a:solidFill>
-                  <a:srgbClr val="FF3621"/>
-                </a:solidFill>
-                <a:latin typeface="Arial" pitchFamily="34" charset="0"/>
-                <a:ea typeface="Arial" pitchFamily="34" charset="-122"/>
-                <a:cs typeface="Arial" pitchFamily="34" charset="-120"/>
-              </a:rPr>
-              <a:t>WHY IT MATTERS NOW</a:t>
-            </a:r>
-            <a:endParaRPr lang="en-US" sz="1100" dirty="0"/>
-          </a:p>
-          <a:p>
-            <a:pPr indent="0" marL="0">
+          <a:p>
+            <a:pPr marL="0" indent="0">
               <a:spcAft>
                 <a:spcPts val="300"/>
               </a:spcAft>
@@ -1956,6 +1667,13 @@
             <a:prstDash val="solid"/>
           </a:ln>
         </p:spPr>
+        <p:txBody>
+          <a:bodyPr/>
+          <a:lstStyle/>
+          <a:p>
+            <a:endParaRPr lang="en-US"/>
+          </a:p>
+        </p:txBody>
       </p:sp>
       <p:sp>
         <p:nvSpPr>
@@ -1978,7 +1696,7 @@
           <a:bodyPr wrap="square" lIns="0" tIns="0" rIns="0" bIns="0" rtlCol="0" anchor="ctr"/>
           <a:lstStyle/>
           <a:p>
-            <a:pPr indent="0" marL="0">
+            <a:pPr marL="0" indent="0">
               <a:buNone/>
             </a:pPr>
             <a:r>
@@ -1995,7 +1713,7 @@
             <a:endParaRPr lang="en-US" sz="1300" dirty="0"/>
           </a:p>
           <a:p>
-            <a:pPr indent="0" marL="0">
+            <a:pPr marL="0" indent="0">
               <a:buNone/>
             </a:pPr>
             <a:r>
@@ -2015,7 +1733,7 @@
       </p:sp>
       <p:graphicFrame>
         <p:nvGraphicFramePr>
-          <p:cNvPr id="12" name="Chart 0" descr=""/>
+          <p:cNvPr id="12" name="Chart 0"/>
           <p:cNvGraphicFramePr/>
           <p:nvPr/>
         </p:nvGraphicFramePr>
@@ -2023,9 +1741,9 @@
           <a:off x="6858000" y="2834640"/>
           <a:ext cx="4434840" cy="1920240"/>
         </p:xfrm>
-        <a:graphic xmlns:a="http://schemas.openxmlformats.org/drawingml/2006/main">
+        <a:graphic>
           <a:graphicData uri="http://schemas.openxmlformats.org/drawingml/2006/chart">
-            <c:chart xmlns:c="http://schemas.openxmlformats.org/drawingml/2006/chart" r:id="rId1"/>
+            <c:chart xmlns:c="http://schemas.openxmlformats.org/drawingml/2006/chart" xmlns:r="http://schemas.openxmlformats.org/officeDocument/2006/relationships" r:id="rId3"/>
           </a:graphicData>
         </a:graphic>
       </p:graphicFrame>
@@ -2050,7 +1768,7 @@
           <a:bodyPr wrap="square" lIns="0" tIns="0" rIns="0" bIns="0" rtlCol="0" anchor="ctr"/>
           <a:lstStyle/>
           <a:p>
-            <a:pPr indent="0" marL="0">
+            <a:pPr marL="0" indent="0">
               <a:buNone/>
             </a:pPr>
             <a:r>
@@ -2089,7 +1807,7 @@
           <a:bodyPr wrap="square" lIns="0" tIns="0" rIns="0" bIns="0" rtlCol="0" anchor="t"/>
           <a:lstStyle/>
           <a:p>
-            <a:pPr indent="0" marL="0">
+            <a:pPr marL="0" indent="0">
               <a:buNone/>
             </a:pPr>
             <a:r>
@@ -2103,12 +1821,10 @@
               </a:rPr>
               <a:t>“I've had dengue three times. The third time, I almost died.”</a:t>
             </a:r>
-            <a:endParaRPr lang="en-US" sz="1400" dirty="0"/>
-          </a:p>
-          <a:p>
-            <a:pPr indent="0" marL="0">
-              <a:buNone/>
-            </a:pPr>
+            <a:r>
+              <a:rPr lang="en-US" sz="1400" i="1" dirty="0"/>
+              <a:t> </a:t>
+            </a:r>
             <a:r>
               <a:rPr lang="en-US" sz="1000" dirty="0">
                 <a:solidFill>
@@ -2145,11 +1861,11 @@
           <a:bodyPr wrap="square" lIns="0" tIns="0" rIns="0" bIns="0" rtlCol="0" anchor="ctr"/>
           <a:lstStyle/>
           <a:p>
-            <a:pPr indent="0" marL="0">
-              <a:buNone/>
-            </a:pPr>
-            <a:r>
-              <a:rPr lang="en-US" sz="900" b="1" spc="100" kern="0" dirty="0">
+            <a:pPr marL="0" indent="0">
+              <a:buNone/>
+            </a:pPr>
+            <a:r>
+              <a:rPr lang="en-US" sz="900" b="1" kern="0" spc="100" dirty="0">
                 <a:solidFill>
                   <a:srgbClr val="FF3621"/>
                 </a:solidFill>
@@ -2157,11 +1873,19 @@
                 <a:ea typeface="Arial" pitchFamily="34" charset="-122"/>
                 <a:cs typeface="Arial" pitchFamily="34" charset="-120"/>
               </a:rPr>
-              <a:t>TEAM MEMBERS  </a:t>
-            </a:r>
-            <a:pPr indent="0" marL="0">
-              <a:buNone/>
-            </a:pPr>
+              <a:t>Solo Project  </a:t>
+            </a:r>
+            <a:r>
+              <a:rPr lang="en-US" sz="900" b="1" kern="0" spc="100" dirty="0">
+                <a:solidFill>
+                  <a:srgbClr val="3D4A52"/>
+                </a:solidFill>
+                <a:latin typeface="Arial" pitchFamily="34" charset="0"/>
+                <a:ea typeface="Arial" pitchFamily="34" charset="-122"/>
+                <a:cs typeface="Arial" pitchFamily="34" charset="-120"/>
+              </a:rPr>
+              <a:t>Apollo Joshua</a:t>
+            </a:r>
             <a:r>
               <a:rPr lang="en-US" sz="900" dirty="0">
                 <a:solidFill>
@@ -2171,7 +1895,7 @@
                 <a:ea typeface="Arial" pitchFamily="34" charset="-122"/>
                 <a:cs typeface="Arial" pitchFamily="34" charset="-120"/>
               </a:rPr>
-              <a:t>[Full name] · [Institution] · [Course] · Year [X] · [email]      [Full name] · [Institution] · [Course] · Year [X] · [email]</a:t>
+              <a:t> · Nanyang Technological University · Computer Engineering · Year 2 · POLO0002@e.ntu.edu.sg</a:t>
             </a:r>
             <a:endParaRPr lang="en-US" sz="900" dirty="0"/>
           </a:p>
@@ -2193,6 +1917,7 @@
         <a:solidFill>
           <a:srgbClr val="FFFFFF"/>
         </a:solidFill>
+        <a:effectLst/>
       </p:bgPr>
     </p:bg>
     <p:spTree>
@@ -2233,6 +1958,13 @@
             <a:prstDash val="solid"/>
           </a:ln>
         </p:spPr>
+        <p:txBody>
+          <a:bodyPr/>
+          <a:lstStyle/>
+          <a:p>
+            <a:endParaRPr lang="en-US"/>
+          </a:p>
+        </p:txBody>
       </p:sp>
       <p:sp>
         <p:nvSpPr>
@@ -2255,7 +1987,7 @@
           <a:bodyPr wrap="square" lIns="0" tIns="0" rIns="0" bIns="0" rtlCol="0" anchor="ctr"/>
           <a:lstStyle/>
           <a:p>
-            <a:pPr indent="0" marL="0">
+            <a:pPr marL="0" indent="0">
               <a:buNone/>
             </a:pPr>
             <a:r>
@@ -2294,7 +2026,7 @@
           <a:bodyPr wrap="square" lIns="0" tIns="0" rIns="0" bIns="0" rtlCol="0" anchor="ctr"/>
           <a:lstStyle/>
           <a:p>
-            <a:pPr indent="0" marL="0">
+            <a:pPr marL="0" indent="0">
               <a:buNone/>
             </a:pPr>
             <a:r>
@@ -2333,7 +2065,7 @@
           <a:bodyPr wrap="square" lIns="0" tIns="0" rIns="0" bIns="0" rtlCol="0" anchor="ctr"/>
           <a:lstStyle/>
           <a:p>
-            <a:pPr indent="0" marL="0">
+            <a:pPr marL="0" indent="0">
               <a:buNone/>
             </a:pPr>
             <a:r>
@@ -2372,14 +2104,14 @@
           <a:bodyPr wrap="square" lIns="0" tIns="0" rIns="0" bIns="0" rtlCol="0" anchor="t"/>
           <a:lstStyle/>
           <a:p>
-            <a:pPr indent="0" marL="0">
+            <a:pPr marL="0" indent="0">
               <a:spcAft>
                 <a:spcPts val="300"/>
               </a:spcAft>
               <a:buNone/>
             </a:pPr>
             <a:r>
-              <a:rPr lang="en-US" sz="1100" b="1" spc="100" kern="0" dirty="0">
+              <a:rPr lang="en-US" sz="1100" b="1" kern="0" spc="100" dirty="0">
                 <a:solidFill>
                   <a:srgbClr val="FF3621"/>
                 </a:solidFill>
@@ -2392,7 +2124,7 @@
             <a:endParaRPr lang="en-US" sz="1100" dirty="0"/>
           </a:p>
           <a:p>
-            <a:pPr indent="0" marL="0">
+            <a:pPr marL="0" indent="0">
               <a:spcAft>
                 <a:spcPts val="300"/>
               </a:spcAft>
@@ -2409,31 +2141,81 @@
               </a:rPr>
               <a:t>DengueSUX turns open data into a weekly plan: </a:t>
             </a:r>
-            <a:pPr indent="0" marL="0">
+            <a:r>
+              <a:rPr lang="en-US" sz="1400" b="1" dirty="0">
+                <a:solidFill>
+                  <a:srgbClr val="1B3139"/>
+                </a:solidFill>
+                <a:latin typeface="Arial" pitchFamily="34" charset="0"/>
+                <a:ea typeface="Arial" pitchFamily="34" charset="-122"/>
+                <a:cs typeface="Arial" pitchFamily="34" charset="-120"/>
+              </a:rPr>
+              <a:t>which areas to check first, which blocks to walk, and what to tell residents</a:t>
+            </a:r>
+            <a:r>
+              <a:rPr lang="en-US" sz="1400" dirty="0">
+                <a:solidFill>
+                  <a:srgbClr val="3D4A52"/>
+                </a:solidFill>
+                <a:latin typeface="Arial" pitchFamily="34" charset="0"/>
+                <a:ea typeface="Arial" pitchFamily="34" charset="-122"/>
+                <a:cs typeface="Arial" pitchFamily="34" charset="-120"/>
+              </a:rPr>
+              <a:t>, backed by a 2-week national forecast tested on the 2022 outbreak.</a:t>
+            </a:r>
+            <a:endParaRPr lang="en-US" sz="1100" dirty="0"/>
+          </a:p>
+        </p:txBody>
+      </p:sp>
+      <p:sp>
+        <p:nvSpPr>
+          <p:cNvPr id="7" name="Text 5"/>
+          <p:cNvSpPr txBox="1"/>
+          <p:nvPr/>
+        </p:nvSpPr>
+        <p:spPr>
+          <a:xfrm>
+            <a:off x="822960" y="2697480"/>
+            <a:ext cx="5486400" cy="1051560"/>
+          </a:xfrm>
+          <a:prstGeom prst="rect">
+            <a:avLst/>
+          </a:prstGeom>
+          <a:noFill/>
+          <a:ln/>
+        </p:spPr>
+        <p:txBody>
+          <a:bodyPr wrap="square" lIns="0" tIns="0" rIns="0" bIns="0" rtlCol="0" anchor="t"/>
+          <a:lstStyle/>
+          <a:p>
+            <a:pPr marL="0" indent="0">
               <a:spcAft>
                 <a:spcPts val="300"/>
               </a:spcAft>
               <a:buNone/>
             </a:pPr>
             <a:r>
-              <a:rPr lang="en-US" sz="1400" b="1" dirty="0">
-                <a:solidFill>
-                  <a:srgbClr val="1B3139"/>
-                </a:solidFill>
-                <a:latin typeface="Arial" pitchFamily="34" charset="0"/>
-                <a:ea typeface="Arial" pitchFamily="34" charset="-122"/>
-                <a:cs typeface="Arial" pitchFamily="34" charset="-120"/>
-              </a:rPr>
-              <a:t>which areas to check first, which blocks to walk, and what to tell residents</a:t>
-            </a:r>
-            <a:pPr indent="0" marL="0">
+              <a:rPr lang="en-US" sz="1100" b="1" kern="0" spc="100" dirty="0">
+                <a:solidFill>
+                  <a:srgbClr val="FF3621"/>
+                </a:solidFill>
+                <a:latin typeface="Arial" pitchFamily="34" charset="0"/>
+                <a:ea typeface="Arial" pitchFamily="34" charset="-122"/>
+                <a:cs typeface="Arial" pitchFamily="34" charset="-120"/>
+              </a:rPr>
+              <a:t>WHO USES IT, AND WHAT DECISION IT CHANGES</a:t>
+            </a:r>
+            <a:endParaRPr lang="en-US" sz="1100" dirty="0"/>
+          </a:p>
+          <a:p>
+            <a:pPr marL="0" indent="0">
               <a:spcAft>
                 <a:spcPts val="300"/>
               </a:spcAft>
               <a:buNone/>
             </a:pPr>
             <a:r>
-              <a:rPr lang="en-US" sz="1400" dirty="0">
+              <a:rPr lang="en-US" sz="1300" dirty="0">
                 <a:solidFill>
                   <a:srgbClr val="3D4A52"/>
                 </a:solidFill>
@@ -2441,7 +2223,29 @@
                 <a:ea typeface="Arial" pitchFamily="34" charset="-122"/>
                 <a:cs typeface="Arial" pitchFamily="34" charset="-120"/>
               </a:rPr>
-              <a:t>, backed by a 2-week national forecast tested on the 2022 outbreak.</a:t>
+              <a:t>Town council officers and grassroots volunteers decide </a:t>
+            </a:r>
+            <a:r>
+              <a:rPr lang="en-US" sz="1300" b="1" dirty="0">
+                <a:solidFill>
+                  <a:srgbClr val="1B3139"/>
+                </a:solidFill>
+                <a:latin typeface="Arial" pitchFamily="34" charset="0"/>
+                <a:ea typeface="Arial" pitchFamily="34" charset="-122"/>
+                <a:cs typeface="Arial" pitchFamily="34" charset="-120"/>
+              </a:rPr>
+              <a:t>where to inspect this week and in what order</a:t>
+            </a:r>
+            <a:r>
+              <a:rPr lang="en-US" sz="1300" dirty="0">
+                <a:solidFill>
+                  <a:srgbClr val="3D4A52"/>
+                </a:solidFill>
+                <a:latin typeface="Arial" pitchFamily="34" charset="0"/>
+                <a:ea typeface="Arial" pitchFamily="34" charset="-122"/>
+                <a:cs typeface="Arial" pitchFamily="34" charset="-120"/>
+              </a:rPr>
+              <a:t>, starting from 8 ranked stops instead of a whole estate. Residents get a notice in their own language.</a:t>
             </a:r>
             <a:endParaRPr lang="en-US" sz="1100" dirty="0"/>
           </a:p>
@@ -2449,14 +2253,14 @@
       </p:sp>
       <p:sp>
         <p:nvSpPr>
-          <p:cNvPr id="7" name="Text 5"/>
+          <p:cNvPr id="8" name="Text 6"/>
           <p:cNvSpPr txBox="1"/>
           <p:nvPr/>
         </p:nvSpPr>
         <p:spPr>
           <a:xfrm>
-            <a:off x="822960" y="2697480"/>
-            <a:ext cx="5486400" cy="1051560"/>
+            <a:off x="822960" y="3840480"/>
+            <a:ext cx="5486400" cy="228600"/>
           </a:xfrm>
           <a:prstGeom prst="rect">
             <a:avLst/>
@@ -2465,110 +2269,14 @@
           <a:ln/>
         </p:spPr>
         <p:txBody>
-          <a:bodyPr wrap="square" lIns="0" tIns="0" rIns="0" bIns="0" rtlCol="0" anchor="t"/>
-          <a:lstStyle/>
-          <a:p>
-            <a:pPr indent="0" marL="0">
-              <a:spcAft>
-                <a:spcPts val="300"/>
-              </a:spcAft>
-              <a:buNone/>
-            </a:pPr>
-            <a:r>
-              <a:rPr lang="en-US" sz="1100" b="1" spc="100" kern="0" dirty="0">
-                <a:solidFill>
-                  <a:srgbClr val="FF3621"/>
-                </a:solidFill>
-                <a:latin typeface="Arial" pitchFamily="34" charset="0"/>
-                <a:ea typeface="Arial" pitchFamily="34" charset="-122"/>
-                <a:cs typeface="Arial" pitchFamily="34" charset="-120"/>
-              </a:rPr>
-              <a:t>WHO USES IT, AND WHAT DECISION IT CHANGES</a:t>
-            </a:r>
-            <a:endParaRPr lang="en-US" sz="1100" dirty="0"/>
-          </a:p>
-          <a:p>
-            <a:pPr indent="0" marL="0">
-              <a:spcAft>
-                <a:spcPts val="300"/>
-              </a:spcAft>
-              <a:buNone/>
-            </a:pPr>
-            <a:r>
-              <a:rPr lang="en-US" sz="1300" dirty="0">
-                <a:solidFill>
-                  <a:srgbClr val="3D4A52"/>
-                </a:solidFill>
-                <a:latin typeface="Arial" pitchFamily="34" charset="0"/>
-                <a:ea typeface="Arial" pitchFamily="34" charset="-122"/>
-                <a:cs typeface="Arial" pitchFamily="34" charset="-120"/>
-              </a:rPr>
-              <a:t>Town council officers and grassroots volunteers decide </a:t>
-            </a:r>
-            <a:pPr indent="0" marL="0">
-              <a:spcAft>
-                <a:spcPts val="300"/>
-              </a:spcAft>
-              <a:buNone/>
-            </a:pPr>
-            <a:r>
-              <a:rPr lang="en-US" sz="1300" b="1" dirty="0">
-                <a:solidFill>
-                  <a:srgbClr val="1B3139"/>
-                </a:solidFill>
-                <a:latin typeface="Arial" pitchFamily="34" charset="0"/>
-                <a:ea typeface="Arial" pitchFamily="34" charset="-122"/>
-                <a:cs typeface="Arial" pitchFamily="34" charset="-120"/>
-              </a:rPr>
-              <a:t>where to inspect this week and in what order</a:t>
-            </a:r>
-            <a:pPr indent="0" marL="0">
-              <a:spcAft>
-                <a:spcPts val="300"/>
-              </a:spcAft>
-              <a:buNone/>
-            </a:pPr>
-            <a:r>
-              <a:rPr lang="en-US" sz="1300" dirty="0">
-                <a:solidFill>
-                  <a:srgbClr val="3D4A52"/>
-                </a:solidFill>
-                <a:latin typeface="Arial" pitchFamily="34" charset="0"/>
-                <a:ea typeface="Arial" pitchFamily="34" charset="-122"/>
-                <a:cs typeface="Arial" pitchFamily="34" charset="-120"/>
-              </a:rPr>
-              <a:t>, starting from 8 ranked stops instead of a whole estate. Residents get a notice in their own language.</a:t>
-            </a:r>
-            <a:endParaRPr lang="en-US" sz="1100" dirty="0"/>
-          </a:p>
-        </p:txBody>
-      </p:sp>
-      <p:sp>
-        <p:nvSpPr>
-          <p:cNvPr id="8" name="Text 6"/>
-          <p:cNvSpPr txBox="1"/>
-          <p:nvPr/>
-        </p:nvSpPr>
-        <p:spPr>
-          <a:xfrm>
-            <a:off x="822960" y="3840480"/>
-            <a:ext cx="5486400" cy="228600"/>
-          </a:xfrm>
-          <a:prstGeom prst="rect">
-            <a:avLst/>
-          </a:prstGeom>
-          <a:noFill/>
-          <a:ln/>
-        </p:spPr>
-        <p:txBody>
           <a:bodyPr wrap="square" lIns="0" tIns="0" rIns="0" bIns="0" rtlCol="0" anchor="ctr"/>
           <a:lstStyle/>
           <a:p>
-            <a:pPr indent="0" marL="0">
-              <a:buNone/>
-            </a:pPr>
-            <a:r>
-              <a:rPr lang="en-US" sz="1100" b="1" spc="100" kern="0" dirty="0">
+            <a:pPr marL="0" indent="0">
+              <a:buNone/>
+            </a:pPr>
+            <a:r>
+              <a:rPr lang="en-US" sz="1100" b="1" kern="0" spc="100" dirty="0">
                 <a:solidFill>
                   <a:srgbClr val="FF3621"/>
                 </a:solidFill>
@@ -2608,6 +2316,13 @@
             <a:prstDash val="solid"/>
           </a:ln>
         </p:spPr>
+        <p:txBody>
+          <a:bodyPr/>
+          <a:lstStyle/>
+          <a:p>
+            <a:endParaRPr lang="en-US"/>
+          </a:p>
+        </p:txBody>
       </p:sp>
       <p:sp>
         <p:nvSpPr>
@@ -2630,7 +2345,7 @@
           <a:bodyPr wrap="square" lIns="0" tIns="0" rIns="0" bIns="0" rtlCol="0" anchor="t"/>
           <a:lstStyle/>
           <a:p>
-            <a:pPr indent="0" marL="0">
+            <a:pPr marL="0" indent="0">
               <a:spcAft>
                 <a:spcPts val="200"/>
               </a:spcAft>
@@ -2650,7 +2365,7 @@
             <a:endParaRPr lang="en-US" sz="1150" dirty="0"/>
           </a:p>
           <a:p>
-            <a:pPr indent="0" marL="0">
+            <a:pPr marL="0" indent="0">
               <a:spcAft>
                 <a:spcPts val="200"/>
               </a:spcAft>
@@ -2697,6 +2412,13 @@
             <a:prstDash val="solid"/>
           </a:ln>
         </p:spPr>
+        <p:txBody>
+          <a:bodyPr/>
+          <a:lstStyle/>
+          <a:p>
+            <a:endParaRPr lang="en-US"/>
+          </a:p>
+        </p:txBody>
       </p:sp>
       <p:sp>
         <p:nvSpPr>
@@ -2719,7 +2441,7 @@
           <a:bodyPr wrap="square" lIns="0" tIns="0" rIns="0" bIns="0" rtlCol="0" anchor="t"/>
           <a:lstStyle/>
           <a:p>
-            <a:pPr indent="0" marL="0">
+            <a:pPr marL="0" indent="0">
               <a:spcAft>
                 <a:spcPts val="200"/>
               </a:spcAft>
@@ -2739,7 +2461,7 @@
             <a:endParaRPr lang="en-US" sz="1150" dirty="0"/>
           </a:p>
           <a:p>
-            <a:pPr indent="0" marL="0">
+            <a:pPr marL="0" indent="0">
               <a:spcAft>
                 <a:spcPts val="200"/>
               </a:spcAft>
@@ -2786,6 +2508,13 @@
             <a:prstDash val="solid"/>
           </a:ln>
         </p:spPr>
+        <p:txBody>
+          <a:bodyPr/>
+          <a:lstStyle/>
+          <a:p>
+            <a:endParaRPr lang="en-US"/>
+          </a:p>
+        </p:txBody>
       </p:sp>
       <p:sp>
         <p:nvSpPr>
@@ -2808,7 +2537,7 @@
           <a:bodyPr wrap="square" lIns="0" tIns="0" rIns="0" bIns="0" rtlCol="0" anchor="t"/>
           <a:lstStyle/>
           <a:p>
-            <a:pPr indent="0" marL="0">
+            <a:pPr marL="0" indent="0">
               <a:spcAft>
                 <a:spcPts val="200"/>
               </a:spcAft>
@@ -2820,15 +2549,14 @@
                   <a:srgbClr val="1B3139"/>
                 </a:solidFill>
                 <a:latin typeface="Arial" pitchFamily="34" charset="0"/>
-                <a:ea typeface="Arial" pitchFamily="34" charset="-122"/>
-                <a:cs typeface="Arial" pitchFamily="34" charset="-120"/>
-              </a:rPr>
-              <a:t>Explains every number</a:t>
+                <a:cs typeface="Arial" pitchFamily="34" charset="-120"/>
+              </a:rPr>
+              <a:t>AI Analysis</a:t>
             </a:r>
             <a:endParaRPr lang="en-US" sz="1150" dirty="0"/>
           </a:p>
           <a:p>
-            <a:pPr indent="0" marL="0">
+            <a:pPr marL="0" indent="0">
               <a:spcAft>
                 <a:spcPts val="200"/>
               </a:spcAft>
@@ -2843,7 +2571,7 @@
                 <a:ea typeface="Arial" pitchFamily="34" charset="-122"/>
                 <a:cs typeface="Arial" pitchFamily="34" charset="-120"/>
               </a:rPr>
-              <a:t>Top drivers and a dated source on every figure. Places to check, never “breeding sites found”.</a:t>
+              <a:t>Top drivers and a dated source on every figure. Places to check for fumigation and maintenance suggestions.</a:t>
             </a:r>
             <a:endParaRPr lang="en-US" sz="1150" dirty="0"/>
           </a:p>
@@ -2875,6 +2603,13 @@
             <a:prstDash val="solid"/>
           </a:ln>
         </p:spPr>
+        <p:txBody>
+          <a:bodyPr/>
+          <a:lstStyle/>
+          <a:p>
+            <a:endParaRPr lang="en-US"/>
+          </a:p>
+        </p:txBody>
       </p:sp>
       <p:sp>
         <p:nvSpPr>
@@ -2897,7 +2632,7 @@
           <a:bodyPr wrap="square" lIns="0" tIns="0" rIns="0" bIns="0" rtlCol="0" anchor="t"/>
           <a:lstStyle/>
           <a:p>
-            <a:pPr indent="0" marL="0">
+            <a:pPr marL="0" indent="0">
               <a:spcAft>
                 <a:spcPts val="200"/>
               </a:spcAft>
@@ -2917,7 +2652,7 @@
             <a:endParaRPr lang="en-US" sz="1150" dirty="0"/>
           </a:p>
           <a:p>
-            <a:pPr indent="0" marL="0">
+            <a:pPr marL="0" indent="0">
               <a:spcAft>
                 <a:spcPts val="200"/>
               </a:spcAft>
@@ -2964,6 +2699,13 @@
             <a:prstDash val="solid"/>
           </a:ln>
         </p:spPr>
+        <p:txBody>
+          <a:bodyPr/>
+          <a:lstStyle/>
+          <a:p>
+            <a:endParaRPr lang="en-US"/>
+          </a:p>
+        </p:txBody>
       </p:sp>
       <p:sp>
         <p:nvSpPr>
@@ -2986,11 +2728,11 @@
           <a:bodyPr wrap="square" lIns="0" tIns="0" rIns="0" bIns="0" rtlCol="0" anchor="ctr"/>
           <a:lstStyle/>
           <a:p>
-            <a:pPr indent="0" marL="0">
-              <a:buNone/>
-            </a:pPr>
-            <a:r>
-              <a:rPr lang="en-US" sz="1100" b="1" spc="100" kern="0" dirty="0">
+            <a:pPr marL="0" indent="0">
+              <a:buNone/>
+            </a:pPr>
+            <a:r>
+              <a:rPr lang="en-US" sz="1100" b="1" kern="0" spc="100" dirty="0">
                 <a:solidFill>
                   <a:srgbClr val="FF3621"/>
                 </a:solidFill>
@@ -3028,6 +2770,13 @@
             <a:prstDash val="solid"/>
           </a:ln>
         </p:spPr>
+        <p:txBody>
+          <a:bodyPr/>
+          <a:lstStyle/>
+          <a:p>
+            <a:endParaRPr lang="en-US"/>
+          </a:p>
+        </p:txBody>
       </p:sp>
       <p:sp>
         <p:nvSpPr>
@@ -3050,7 +2799,7 @@
           <a:bodyPr wrap="square" lIns="0" tIns="0" rIns="0" bIns="0" rtlCol="0" anchor="ctr"/>
           <a:lstStyle/>
           <a:p>
-            <a:pPr algn="ctr" indent="0" marL="0">
+            <a:pPr marL="0" indent="0" algn="ctr">
               <a:buNone/>
             </a:pPr>
             <a:r>
@@ -3089,7 +2838,7 @@
           <a:bodyPr wrap="square" lIns="0" tIns="0" rIns="0" bIns="0" rtlCol="0" anchor="t"/>
           <a:lstStyle/>
           <a:p>
-            <a:pPr indent="0" marL="0">
+            <a:pPr marL="0" indent="0">
               <a:buNone/>
             </a:pPr>
             <a:r>
@@ -3106,7 +2855,7 @@
             <a:endParaRPr lang="en-US" sz="1100" dirty="0"/>
           </a:p>
           <a:p>
-            <a:pPr indent="0" marL="0">
+            <a:pPr marL="0" indent="0">
               <a:buNone/>
             </a:pPr>
             <a:r>
@@ -3148,6 +2897,13 @@
             <a:prstDash val="solid"/>
           </a:ln>
         </p:spPr>
+        <p:txBody>
+          <a:bodyPr/>
+          <a:lstStyle/>
+          <a:p>
+            <a:endParaRPr lang="en-US"/>
+          </a:p>
+        </p:txBody>
       </p:sp>
       <p:sp>
         <p:nvSpPr>
@@ -3170,7 +2926,7 @@
           <a:bodyPr wrap="square" lIns="0" tIns="0" rIns="0" bIns="0" rtlCol="0" anchor="ctr"/>
           <a:lstStyle/>
           <a:p>
-            <a:pPr algn="ctr" indent="0" marL="0">
+            <a:pPr marL="0" indent="0" algn="ctr">
               <a:buNone/>
             </a:pPr>
             <a:r>
@@ -3209,7 +2965,7 @@
           <a:bodyPr wrap="square" lIns="0" tIns="0" rIns="0" bIns="0" rtlCol="0" anchor="t"/>
           <a:lstStyle/>
           <a:p>
-            <a:pPr indent="0" marL="0">
+            <a:pPr marL="0" indent="0">
               <a:buNone/>
             </a:pPr>
             <a:r>
@@ -3226,7 +2982,7 @@
             <a:endParaRPr lang="en-US" sz="1100" dirty="0"/>
           </a:p>
           <a:p>
-            <a:pPr indent="0" marL="0">
+            <a:pPr marL="0" indent="0">
               <a:buNone/>
             </a:pPr>
             <a:r>
@@ -3268,6 +3024,13 @@
             <a:prstDash val="solid"/>
           </a:ln>
         </p:spPr>
+        <p:txBody>
+          <a:bodyPr/>
+          <a:lstStyle/>
+          <a:p>
+            <a:endParaRPr lang="en-US"/>
+          </a:p>
+        </p:txBody>
       </p:sp>
       <p:sp>
         <p:nvSpPr>
@@ -3290,7 +3053,7 @@
           <a:bodyPr wrap="square" lIns="0" tIns="0" rIns="0" bIns="0" rtlCol="0" anchor="ctr"/>
           <a:lstStyle/>
           <a:p>
-            <a:pPr algn="ctr" indent="0" marL="0">
+            <a:pPr marL="0" indent="0" algn="ctr">
               <a:buNone/>
             </a:pPr>
             <a:r>
@@ -3329,7 +3092,7 @@
           <a:bodyPr wrap="square" lIns="0" tIns="0" rIns="0" bIns="0" rtlCol="0" anchor="t"/>
           <a:lstStyle/>
           <a:p>
-            <a:pPr indent="0" marL="0">
+            <a:pPr marL="0" indent="0">
               <a:buNone/>
             </a:pPr>
             <a:r>
@@ -3346,7 +3109,7 @@
             <a:endParaRPr lang="en-US" sz="1100" dirty="0"/>
           </a:p>
           <a:p>
-            <a:pPr indent="0" marL="0">
+            <a:pPr marL="0" indent="0">
               <a:buNone/>
             </a:pPr>
             <a:r>
@@ -3388,6 +3151,13 @@
             <a:prstDash val="solid"/>
           </a:ln>
         </p:spPr>
+        <p:txBody>
+          <a:bodyPr/>
+          <a:lstStyle/>
+          <a:p>
+            <a:endParaRPr lang="en-US"/>
+          </a:p>
+        </p:txBody>
       </p:sp>
       <p:sp>
         <p:nvSpPr>
@@ -3410,7 +3180,7 @@
           <a:bodyPr wrap="square" lIns="0" tIns="0" rIns="0" bIns="0" rtlCol="0" anchor="ctr"/>
           <a:lstStyle/>
           <a:p>
-            <a:pPr algn="ctr" indent="0" marL="0">
+            <a:pPr marL="0" indent="0" algn="ctr">
               <a:buNone/>
             </a:pPr>
             <a:r>
@@ -3449,7 +3219,7 @@
           <a:bodyPr wrap="square" lIns="0" tIns="0" rIns="0" bIns="0" rtlCol="0" anchor="t"/>
           <a:lstStyle/>
           <a:p>
-            <a:pPr indent="0" marL="0">
+            <a:pPr marL="0" indent="0">
               <a:buNone/>
             </a:pPr>
             <a:r>
@@ -3466,7 +3236,7 @@
             <a:endParaRPr lang="en-US" sz="1100" dirty="0"/>
           </a:p>
           <a:p>
-            <a:pPr indent="0" marL="0">
+            <a:pPr marL="0" indent="0">
               <a:buNone/>
             </a:pPr>
             <a:r>
@@ -3508,6 +3278,13 @@
             <a:prstDash val="solid"/>
           </a:ln>
         </p:spPr>
+        <p:txBody>
+          <a:bodyPr/>
+          <a:lstStyle/>
+          <a:p>
+            <a:endParaRPr lang="en-US"/>
+          </a:p>
+        </p:txBody>
       </p:sp>
       <p:sp>
         <p:nvSpPr>
@@ -3530,7 +3307,7 @@
           <a:bodyPr wrap="square" lIns="0" tIns="0" rIns="0" bIns="0" rtlCol="0" anchor="ctr"/>
           <a:lstStyle/>
           <a:p>
-            <a:pPr algn="ctr" indent="0" marL="0">
+            <a:pPr marL="0" indent="0" algn="ctr">
               <a:buNone/>
             </a:pPr>
             <a:r>
@@ -3569,7 +3346,7 @@
           <a:bodyPr wrap="square" lIns="0" tIns="0" rIns="0" bIns="0" rtlCol="0" anchor="t"/>
           <a:lstStyle/>
           <a:p>
-            <a:pPr indent="0" marL="0">
+            <a:pPr marL="0" indent="0">
               <a:buNone/>
             </a:pPr>
             <a:r>
@@ -3586,7 +3363,7 @@
             <a:endParaRPr lang="en-US" sz="1100" dirty="0"/>
           </a:p>
           <a:p>
-            <a:pPr indent="0" marL="0">
+            <a:pPr marL="0" indent="0">
               <a:buNone/>
             </a:pPr>
             <a:r>
@@ -3628,6 +3405,13 @@
             <a:prstDash val="solid"/>
           </a:ln>
         </p:spPr>
+        <p:txBody>
+          <a:bodyPr/>
+          <a:lstStyle/>
+          <a:p>
+            <a:endParaRPr lang="en-US"/>
+          </a:p>
+        </p:txBody>
       </p:sp>
       <p:sp>
         <p:nvSpPr>
@@ -3650,7 +3434,7 @@
           <a:bodyPr wrap="square" lIns="0" tIns="0" rIns="0" bIns="0" rtlCol="0" anchor="ctr"/>
           <a:lstStyle/>
           <a:p>
-            <a:pPr algn="ctr" indent="0" marL="0">
+            <a:pPr marL="0" indent="0" algn="ctr">
               <a:buNone/>
             </a:pPr>
             <a:r>
@@ -3689,7 +3473,7 @@
           <a:bodyPr wrap="square" lIns="0" tIns="0" rIns="0" bIns="0" rtlCol="0" anchor="t"/>
           <a:lstStyle/>
           <a:p>
-            <a:pPr indent="0" marL="0">
+            <a:pPr marL="0" indent="0">
               <a:buNone/>
             </a:pPr>
             <a:r>
@@ -3706,7 +3490,7 @@
             <a:endParaRPr lang="en-US" sz="1100" dirty="0"/>
           </a:p>
           <a:p>
-            <a:pPr indent="0" marL="0">
+            <a:pPr marL="0" indent="0">
               <a:buNone/>
             </a:pPr>
             <a:r>
@@ -3748,6 +3532,13 @@
             <a:prstDash val="solid"/>
           </a:ln>
         </p:spPr>
+        <p:txBody>
+          <a:bodyPr/>
+          <a:lstStyle/>
+          <a:p>
+            <a:endParaRPr lang="en-US"/>
+          </a:p>
+        </p:txBody>
       </p:sp>
       <p:sp>
         <p:nvSpPr>
@@ -3770,7 +3561,7 @@
           <a:bodyPr wrap="square" lIns="0" tIns="0" rIns="0" bIns="0" rtlCol="0" anchor="ctr"/>
           <a:lstStyle/>
           <a:p>
-            <a:pPr algn="ctr" indent="0" marL="0">
+            <a:pPr marL="0" indent="0" algn="ctr">
               <a:buNone/>
             </a:pPr>
             <a:r>
@@ -3809,7 +3600,7 @@
           <a:bodyPr wrap="square" lIns="0" tIns="0" rIns="0" bIns="0" rtlCol="0" anchor="t"/>
           <a:lstStyle/>
           <a:p>
-            <a:pPr indent="0" marL="0">
+            <a:pPr marL="0" indent="0">
               <a:buNone/>
             </a:pPr>
             <a:r>
@@ -3826,7 +3617,7 @@
             <a:endParaRPr lang="en-US" sz="1100" dirty="0"/>
           </a:p>
           <a:p>
-            <a:pPr indent="0" marL="0">
+            <a:pPr marL="0" indent="0">
               <a:buNone/>
             </a:pPr>
             <a:r>
@@ -3868,6 +3659,13 @@
             <a:prstDash val="solid"/>
           </a:ln>
         </p:spPr>
+        <p:txBody>
+          <a:bodyPr/>
+          <a:lstStyle/>
+          <a:p>
+            <a:endParaRPr lang="en-US"/>
+          </a:p>
+        </p:txBody>
       </p:sp>
       <p:sp>
         <p:nvSpPr>
@@ -3890,7 +3688,7 @@
           <a:bodyPr wrap="square" lIns="0" tIns="0" rIns="0" bIns="0" rtlCol="0" anchor="ctr"/>
           <a:lstStyle/>
           <a:p>
-            <a:pPr algn="ctr" indent="0" marL="0">
+            <a:pPr marL="0" indent="0" algn="ctr">
               <a:buNone/>
             </a:pPr>
             <a:r>
@@ -3929,7 +3727,7 @@
           <a:bodyPr wrap="square" lIns="0" tIns="0" rIns="0" bIns="0" rtlCol="0" anchor="t"/>
           <a:lstStyle/>
           <a:p>
-            <a:pPr indent="0" marL="0">
+            <a:pPr marL="0" indent="0">
               <a:buNone/>
             </a:pPr>
             <a:r>
@@ -3946,7 +3744,7 @@
             <a:endParaRPr lang="en-US" sz="1100" dirty="0"/>
           </a:p>
           <a:p>
-            <a:pPr indent="0" marL="0">
+            <a:pPr marL="0" indent="0">
               <a:buNone/>
             </a:pPr>
             <a:r>
@@ -3972,7 +3770,7 @@
         </p:nvSpPr>
         <p:spPr>
           <a:xfrm>
-            <a:off x="6903720" y="5458968"/>
+            <a:off x="6903720" y="5541264"/>
             <a:ext cx="4251960" cy="502920"/>
           </a:xfrm>
           <a:prstGeom prst="rect">
@@ -3985,7 +3783,7 @@
           <a:bodyPr wrap="square" lIns="0" tIns="0" rIns="0" bIns="0" rtlCol="0" anchor="t"/>
           <a:lstStyle/>
           <a:p>
-            <a:pPr indent="0" marL="0">
+            <a:pPr marL="0" indent="0">
               <a:buNone/>
             </a:pPr>
             <a:r>
@@ -3999,9 +3797,6 @@
               </a:rPr>
               <a:t>Honest limits: </a:t>
             </a:r>
-            <a:pPr indent="0" marL="0">
-              <a:buNone/>
-            </a:pPr>
             <a:r>
               <a:rPr lang="en-US" sz="950" dirty="0">
                 <a:solidFill>
@@ -4033,6 +3828,7 @@
         <a:solidFill>
           <a:srgbClr val="FFFFFF"/>
         </a:solidFill>
+        <a:effectLst/>
       </p:bgPr>
     </p:bg>
     <p:spTree>
@@ -4073,6 +3869,13 @@
             <a:prstDash val="solid"/>
           </a:ln>
         </p:spPr>
+        <p:txBody>
+          <a:bodyPr/>
+          <a:lstStyle/>
+          <a:p>
+            <a:endParaRPr lang="en-US"/>
+          </a:p>
+        </p:txBody>
       </p:sp>
       <p:sp>
         <p:nvSpPr>
@@ -4095,7 +3898,7 @@
           <a:bodyPr wrap="square" lIns="0" tIns="0" rIns="0" bIns="0" rtlCol="0" anchor="ctr"/>
           <a:lstStyle/>
           <a:p>
-            <a:pPr indent="0" marL="0">
+            <a:pPr marL="0" indent="0">
               <a:buNone/>
             </a:pPr>
             <a:r>
@@ -4134,7 +3937,7 @@
           <a:bodyPr wrap="square" lIns="0" tIns="0" rIns="0" bIns="0" rtlCol="0" anchor="ctr"/>
           <a:lstStyle/>
           <a:p>
-            <a:pPr indent="0" marL="0">
+            <a:pPr marL="0" indent="0">
               <a:buNone/>
             </a:pPr>
             <a:r>
@@ -4173,7 +3976,7 @@
           <a:bodyPr wrap="square" lIns="0" tIns="0" rIns="0" bIns="0" rtlCol="0" anchor="ctr"/>
           <a:lstStyle/>
           <a:p>
-            <a:pPr indent="0" marL="0">
+            <a:pPr marL="0" indent="0">
               <a:buNone/>
             </a:pPr>
             <a:r>
@@ -4217,6 +4020,13 @@
             <a:prstDash val="solid"/>
           </a:ln>
         </p:spPr>
+        <p:txBody>
+          <a:bodyPr/>
+          <a:lstStyle/>
+          <a:p>
+            <a:endParaRPr lang="en-US"/>
+          </a:p>
+        </p:txBody>
       </p:sp>
       <p:sp>
         <p:nvSpPr>
@@ -4239,14 +4049,14 @@
           <a:bodyPr wrap="square" lIns="0" tIns="0" rIns="0" bIns="0" rtlCol="0" anchor="t"/>
           <a:lstStyle/>
           <a:p>
-            <a:pPr indent="0" marL="0">
+            <a:pPr marL="0" indent="0">
               <a:spcAft>
                 <a:spcPts val="300"/>
               </a:spcAft>
               <a:buNone/>
             </a:pPr>
             <a:r>
-              <a:rPr lang="en-US" sz="950" b="1" spc="100" kern="0" dirty="0">
+              <a:rPr lang="en-US" sz="950" b="1" kern="0" spc="100" dirty="0">
                 <a:solidFill>
                   <a:srgbClr val="FF3621"/>
                 </a:solidFill>
@@ -4259,7 +4069,7 @@
             <a:endParaRPr lang="en-US" sz="950" dirty="0"/>
           </a:p>
           <a:p>
-            <a:pPr indent="0" marL="0">
+            <a:pPr marL="0" indent="0">
               <a:spcAft>
                 <a:spcPts val="300"/>
               </a:spcAft>
@@ -4279,7 +4089,7 @@
             <a:endParaRPr lang="en-US" sz="950" dirty="0"/>
           </a:p>
           <a:p>
-            <a:pPr indent="0" marL="0">
+            <a:pPr marL="0" indent="0">
               <a:spcAft>
                 <a:spcPts val="300"/>
               </a:spcAft>
@@ -4321,7 +4131,7 @@
           <a:bodyPr wrap="square" lIns="0" tIns="0" rIns="0" bIns="0" rtlCol="0" anchor="ctr"/>
           <a:lstStyle/>
           <a:p>
-            <a:pPr algn="ctr" indent="0" marL="0">
+            <a:pPr marL="0" indent="0" algn="ctr">
               <a:buNone/>
             </a:pPr>
             <a:r>
@@ -4365,6 +4175,13 @@
             <a:prstDash val="solid"/>
           </a:ln>
         </p:spPr>
+        <p:txBody>
+          <a:bodyPr/>
+          <a:lstStyle/>
+          <a:p>
+            <a:endParaRPr lang="en-US"/>
+          </a:p>
+        </p:txBody>
       </p:sp>
       <p:sp>
         <p:nvSpPr>
@@ -4387,14 +4204,14 @@
           <a:bodyPr wrap="square" lIns="0" tIns="0" rIns="0" bIns="0" rtlCol="0" anchor="t"/>
           <a:lstStyle/>
           <a:p>
-            <a:pPr indent="0" marL="0">
+            <a:pPr marL="0" indent="0">
               <a:spcAft>
                 <a:spcPts val="300"/>
               </a:spcAft>
               <a:buNone/>
             </a:pPr>
             <a:r>
-              <a:rPr lang="en-US" sz="950" b="1" spc="100" kern="0" dirty="0">
+              <a:rPr lang="en-US" sz="950" b="1" kern="0" spc="100" dirty="0">
                 <a:solidFill>
                   <a:srgbClr val="FF3621"/>
                 </a:solidFill>
@@ -4407,7 +4224,7 @@
             <a:endParaRPr lang="en-US" sz="950" dirty="0"/>
           </a:p>
           <a:p>
-            <a:pPr indent="0" marL="0">
+            <a:pPr marL="0" indent="0">
               <a:spcAft>
                 <a:spcPts val="300"/>
               </a:spcAft>
@@ -4427,7 +4244,7 @@
             <a:endParaRPr lang="en-US" sz="950" dirty="0"/>
           </a:p>
           <a:p>
-            <a:pPr indent="0" marL="0">
+            <a:pPr marL="0" indent="0">
               <a:spcAft>
                 <a:spcPts val="300"/>
               </a:spcAft>
@@ -4469,7 +4286,7 @@
           <a:bodyPr wrap="square" lIns="0" tIns="0" rIns="0" bIns="0" rtlCol="0" anchor="ctr"/>
           <a:lstStyle/>
           <a:p>
-            <a:pPr algn="ctr" indent="0" marL="0">
+            <a:pPr marL="0" indent="0" algn="ctr">
               <a:buNone/>
             </a:pPr>
             <a:r>
@@ -4513,6 +4330,13 @@
             <a:prstDash val="solid"/>
           </a:ln>
         </p:spPr>
+        <p:txBody>
+          <a:bodyPr/>
+          <a:lstStyle/>
+          <a:p>
+            <a:endParaRPr lang="en-US"/>
+          </a:p>
+        </p:txBody>
       </p:sp>
       <p:sp>
         <p:nvSpPr>
@@ -4535,14 +4359,14 @@
           <a:bodyPr wrap="square" lIns="0" tIns="0" rIns="0" bIns="0" rtlCol="0" anchor="t"/>
           <a:lstStyle/>
           <a:p>
-            <a:pPr indent="0" marL="0">
+            <a:pPr marL="0" indent="0">
               <a:spcAft>
                 <a:spcPts val="300"/>
               </a:spcAft>
               <a:buNone/>
             </a:pPr>
             <a:r>
-              <a:rPr lang="en-US" sz="950" b="1" spc="100" kern="0" dirty="0">
+              <a:rPr lang="en-US" sz="950" b="1" kern="0" spc="100" dirty="0">
                 <a:solidFill>
                   <a:srgbClr val="FF3621"/>
                 </a:solidFill>
@@ -4555,7 +4379,7 @@
             <a:endParaRPr lang="en-US" sz="950" dirty="0"/>
           </a:p>
           <a:p>
-            <a:pPr indent="0" marL="0">
+            <a:pPr marL="0" indent="0">
               <a:spcAft>
                 <a:spcPts val="300"/>
               </a:spcAft>
@@ -4575,7 +4399,7 @@
             <a:endParaRPr lang="en-US" sz="950" dirty="0"/>
           </a:p>
           <a:p>
-            <a:pPr indent="0" marL="0">
+            <a:pPr marL="0" indent="0">
               <a:spcAft>
                 <a:spcPts val="300"/>
               </a:spcAft>
@@ -4617,7 +4441,7 @@
           <a:bodyPr wrap="square" lIns="0" tIns="0" rIns="0" bIns="0" rtlCol="0" anchor="ctr"/>
           <a:lstStyle/>
           <a:p>
-            <a:pPr algn="ctr" indent="0" marL="0">
+            <a:pPr marL="0" indent="0" algn="ctr">
               <a:buNone/>
             </a:pPr>
             <a:r>
@@ -4661,6 +4485,13 @@
             <a:prstDash val="solid"/>
           </a:ln>
         </p:spPr>
+        <p:txBody>
+          <a:bodyPr/>
+          <a:lstStyle/>
+          <a:p>
+            <a:endParaRPr lang="en-US"/>
+          </a:p>
+        </p:txBody>
       </p:sp>
       <p:sp>
         <p:nvSpPr>
@@ -4683,14 +4514,14 @@
           <a:bodyPr wrap="square" lIns="0" tIns="0" rIns="0" bIns="0" rtlCol="0" anchor="t"/>
           <a:lstStyle/>
           <a:p>
-            <a:pPr indent="0" marL="0">
+            <a:pPr marL="0" indent="0">
               <a:spcAft>
                 <a:spcPts val="300"/>
               </a:spcAft>
               <a:buNone/>
             </a:pPr>
             <a:r>
-              <a:rPr lang="en-US" sz="950" b="1" spc="100" kern="0" dirty="0">
+              <a:rPr lang="en-US" sz="950" b="1" kern="0" spc="100" dirty="0">
                 <a:solidFill>
                   <a:srgbClr val="FF3621"/>
                 </a:solidFill>
@@ -4703,7 +4534,7 @@
             <a:endParaRPr lang="en-US" sz="950" dirty="0"/>
           </a:p>
           <a:p>
-            <a:pPr indent="0" marL="0">
+            <a:pPr marL="0" indent="0">
               <a:spcAft>
                 <a:spcPts val="300"/>
               </a:spcAft>
@@ -4723,7 +4554,7 @@
             <a:endParaRPr lang="en-US" sz="950" dirty="0"/>
           </a:p>
           <a:p>
-            <a:pPr indent="0" marL="0">
+            <a:pPr marL="0" indent="0">
               <a:spcAft>
                 <a:spcPts val="300"/>
               </a:spcAft>
@@ -4765,7 +4596,7 @@
           <a:bodyPr wrap="square" lIns="0" tIns="0" rIns="0" bIns="0" rtlCol="0" anchor="ctr"/>
           <a:lstStyle/>
           <a:p>
-            <a:pPr algn="ctr" indent="0" marL="0">
+            <a:pPr marL="0" indent="0" algn="ctr">
               <a:buNone/>
             </a:pPr>
             <a:r>
@@ -4809,6 +4640,13 @@
             <a:prstDash val="solid"/>
           </a:ln>
         </p:spPr>
+        <p:txBody>
+          <a:bodyPr/>
+          <a:lstStyle/>
+          <a:p>
+            <a:endParaRPr lang="en-US"/>
+          </a:p>
+        </p:txBody>
       </p:sp>
       <p:sp>
         <p:nvSpPr>
@@ -4831,14 +4669,14 @@
           <a:bodyPr wrap="square" lIns="0" tIns="0" rIns="0" bIns="0" rtlCol="0" anchor="t"/>
           <a:lstStyle/>
           <a:p>
-            <a:pPr indent="0" marL="0">
+            <a:pPr marL="0" indent="0">
               <a:spcAft>
                 <a:spcPts val="300"/>
               </a:spcAft>
               <a:buNone/>
             </a:pPr>
             <a:r>
-              <a:rPr lang="en-US" sz="950" b="1" spc="100" kern="0" dirty="0">
+              <a:rPr lang="en-US" sz="950" b="1" kern="0" spc="100" dirty="0">
                 <a:solidFill>
                   <a:srgbClr val="FF3621"/>
                 </a:solidFill>
@@ -4851,7 +4689,7 @@
             <a:endParaRPr lang="en-US" sz="950" dirty="0"/>
           </a:p>
           <a:p>
-            <a:pPr indent="0" marL="0">
+            <a:pPr marL="0" indent="0">
               <a:spcAft>
                 <a:spcPts val="300"/>
               </a:spcAft>
@@ -4871,7 +4709,7 @@
             <a:endParaRPr lang="en-US" sz="950" dirty="0"/>
           </a:p>
           <a:p>
-            <a:pPr indent="0" marL="0">
+            <a:pPr marL="0" indent="0">
               <a:spcAft>
                 <a:spcPts val="300"/>
               </a:spcAft>
@@ -4918,6 +4756,13 @@
             <a:prstDash val="solid"/>
           </a:ln>
         </p:spPr>
+        <p:txBody>
+          <a:bodyPr/>
+          <a:lstStyle/>
+          <a:p>
+            <a:endParaRPr lang="en-US"/>
+          </a:p>
+        </p:txBody>
       </p:sp>
       <p:sp>
         <p:nvSpPr>
@@ -4940,11 +4785,11 @@
           <a:bodyPr wrap="square" lIns="0" tIns="0" rIns="0" bIns="0" rtlCol="0" anchor="ctr"/>
           <a:lstStyle/>
           <a:p>
-            <a:pPr indent="0" marL="0">
-              <a:buNone/>
-            </a:pPr>
-            <a:r>
-              <a:rPr lang="en-US" sz="1000" b="1" spc="100" kern="0" dirty="0">
+            <a:pPr marL="0" indent="0">
+              <a:buNone/>
+            </a:pPr>
+            <a:r>
+              <a:rPr lang="en-US" sz="1000" b="1" kern="0" spc="100" dirty="0">
                 <a:solidFill>
                   <a:srgbClr val="FF3621"/>
                 </a:solidFill>
@@ -4954,9 +4799,6 @@
               </a:rPr>
               <a:t>UNITY CATALOG  </a:t>
             </a:r>
-            <a:pPr indent="0" marL="0">
-              <a:buNone/>
-            </a:pPr>
             <a:r>
               <a:rPr lang="en-US" sz="1100" dirty="0">
                 <a:solidFill>
@@ -4993,11 +4835,11 @@
           <a:bodyPr wrap="square" lIns="0" tIns="0" rIns="0" bIns="0" rtlCol="0" anchor="ctr"/>
           <a:lstStyle/>
           <a:p>
-            <a:pPr indent="0" marL="0">
-              <a:buNone/>
-            </a:pPr>
-            <a:r>
-              <a:rPr lang="en-US" sz="1100" b="1" spc="100" kern="0" dirty="0">
+            <a:pPr marL="0" indent="0">
+              <a:buNone/>
+            </a:pPr>
+            <a:r>
+              <a:rPr lang="en-US" sz="1100" b="1" kern="0" spc="100" dirty="0">
                 <a:solidFill>
                   <a:srgbClr val="FF3621"/>
                 </a:solidFill>
@@ -5013,14 +4855,14 @@
       </p:sp>
       <p:pic>
         <p:nvPicPr>
-          <p:cNvPr id="23" name="Image 0" descr="slide3_inspection.png">    </p:cNvPr>
+          <p:cNvPr id="23" name="Image 0" descr="slide3_inspection.png"/>
           <p:cNvPicPr>
             <a:picLocks noChangeAspect="1"/>
           </p:cNvPicPr>
           <p:nvPr/>
         </p:nvPicPr>
         <p:blipFill>
-          <a:blip r:embed="rId1"/>
+          <a:blip r:embed="rId3"/>
           <a:stretch>
             <a:fillRect/>
           </a:stretch>
@@ -5056,7 +4898,7 @@
           <a:bodyPr wrap="square" lIns="0" tIns="0" rIns="0" bIns="0" rtlCol="0" anchor="t"/>
           <a:lstStyle/>
           <a:p>
-            <a:pPr indent="0" marL="0">
+            <a:pPr marL="0" indent="0">
               <a:buNone/>
             </a:pPr>
             <a:r>
@@ -5095,11 +4937,11 @@
           <a:bodyPr wrap="square" lIns="0" tIns="0" rIns="0" bIns="0" rtlCol="0" anchor="ctr"/>
           <a:lstStyle/>
           <a:p>
-            <a:pPr indent="0" marL="0">
-              <a:buNone/>
-            </a:pPr>
-            <a:r>
-              <a:rPr lang="en-US" sz="1100" b="1" spc="100" kern="0" dirty="0">
+            <a:pPr marL="0" indent="0">
+              <a:buNone/>
+            </a:pPr>
+            <a:r>
+              <a:rPr lang="en-US" sz="1100" b="1" kern="0" spc="100" dirty="0">
                 <a:solidFill>
                   <a:srgbClr val="FF3621"/>
                 </a:solidFill>
@@ -5240,11 +5082,11 @@
           <a:bodyPr wrap="square" lIns="0" tIns="0" rIns="0" bIns="0" rtlCol="0" anchor="ctr"/>
           <a:lstStyle/>
           <a:p>
-            <a:pPr indent="0" marL="0">
-              <a:buNone/>
-            </a:pPr>
-            <a:r>
-              <a:rPr lang="en-US" sz="1100" b="1" spc="100" kern="0" dirty="0">
+            <a:pPr marL="0" indent="0">
+              <a:buNone/>
+            </a:pPr>
+            <a:r>
+              <a:rPr lang="en-US" sz="1100" b="1" kern="0" spc="100" dirty="0">
                 <a:solidFill>
                   <a:srgbClr val="FF3621"/>
                 </a:solidFill>
@@ -5665,4 +5507,319 @@
     </a:ext>
   </a:extLst>
 </a:theme>
+</file>
+
+<file path=ppt/theme/theme2.xml><?xml version="1.0" encoding="utf-8"?>
+<a:theme xmlns:a="http://schemas.openxmlformats.org/drawingml/2006/main" name="Office Theme">
+  <a:themeElements>
+    <a:clrScheme name="Office">
+      <a:dk1>
+        <a:sysClr val="windowText" lastClr="000000"/>
+      </a:dk1>
+      <a:lt1>
+        <a:sysClr val="window" lastClr="FFFFFF"/>
+      </a:lt1>
+      <a:dk2>
+        <a:srgbClr val="0E2841"/>
+      </a:dk2>
+      <a:lt2>
+        <a:srgbClr val="E8E8E8"/>
+      </a:lt2>
+      <a:accent1>
+        <a:srgbClr val="156082"/>
+      </a:accent1>
+      <a:accent2>
+        <a:srgbClr val="E97132"/>
+      </a:accent2>
+      <a:accent3>
+        <a:srgbClr val="196B24"/>
+      </a:accent3>
+      <a:accent4>
+        <a:srgbClr val="0F9ED5"/>
+      </a:accent4>
+      <a:accent5>
+        <a:srgbClr val="A02B93"/>
+      </a:accent5>
+      <a:accent6>
+        <a:srgbClr val="4EA72E"/>
+      </a:accent6>
+      <a:hlink>
+        <a:srgbClr val="467886"/>
+      </a:hlink>
+      <a:folHlink>
+        <a:srgbClr val="96607D"/>
+      </a:folHlink>
+    </a:clrScheme>
+    <a:fontScheme name="Office">
+      <a:majorFont>
+        <a:latin typeface="Aptos Display" panose="02110004020202020204"/>
+        <a:ea typeface=""/>
+        <a:cs typeface=""/>
+        <a:font script="Jpan" typeface="游ゴシック Light"/>
+        <a:font script="Hang" typeface="맑은 고딕"/>
+        <a:font script="Hans" typeface="等线 Light"/>
+        <a:font script="Hant" typeface="新細明體"/>
+        <a:font script="Arab" typeface="Times New Roman"/>
+        <a:font script="Hebr" typeface="Times New Roman"/>
+        <a:font script="Thai" typeface="Angsana New"/>
+        <a:font script="Ethi" typeface="Nyala"/>
+        <a:font script="Beng" typeface="Vrinda"/>
+        <a:font script="Gujr" typeface="Shruti"/>
+        <a:font script="Khmr" typeface="MoolBoran"/>
+        <a:font script="Knda" typeface="Tunga"/>
+        <a:font script="Guru" typeface="Raavi"/>
+        <a:font script="Cans" typeface="Euphemia"/>
+        <a:font script="Cher" typeface="Plantagenet Cherokee"/>
+        <a:font script="Yiii" typeface="Microsoft Yi Baiti"/>
+        <a:font script="Tibt" typeface="Microsoft Himalaya"/>
+        <a:font script="Thaa" typeface="MV Boli"/>
+        <a:font script="Deva" typeface="Mangal"/>
+        <a:font script="Telu" typeface="Gautami"/>
+        <a:font script="Taml" typeface="Latha"/>
+        <a:font script="Syrc" typeface="Estrangelo Edessa"/>
+        <a:font script="Orya" typeface="Kalinga"/>
+        <a:font script="Mlym" typeface="Kartika"/>
+        <a:font script="Laoo" typeface="DokChampa"/>
+        <a:font script="Sinh" typeface="Iskoola Pota"/>
+        <a:font script="Mong" typeface="Mongolian Baiti"/>
+        <a:font script="Viet" typeface="Times New Roman"/>
+        <a:font script="Uigh" typeface="Microsoft Uighur"/>
+        <a:font script="Geor" typeface="Sylfaen"/>
+        <a:font script="Armn" typeface="Arial"/>
+        <a:font script="Bugi" typeface="Leelawadee UI"/>
+        <a:font script="Bopo" typeface="Microsoft JhengHei"/>
+        <a:font script="Java" typeface="Javanese Text"/>
+        <a:font script="Lisu" typeface="Segoe UI"/>
+        <a:font script="Mymr" typeface="Myanmar Text"/>
+        <a:font script="Nkoo" typeface="Ebrima"/>
+        <a:font script="Olck" typeface="Nirmala UI"/>
+        <a:font script="Osma" typeface="Ebrima"/>
+        <a:font script="Phag" typeface="Phagspa"/>
+        <a:font script="Syrn" typeface="Estrangelo Edessa"/>
+        <a:font script="Syrj" typeface="Estrangelo Edessa"/>
+        <a:font script="Syre" typeface="Estrangelo Edessa"/>
+        <a:font script="Sora" typeface="Nirmala UI"/>
+        <a:font script="Tale" typeface="Microsoft Tai Le"/>
+        <a:font script="Talu" typeface="Microsoft New Tai Lue"/>
+        <a:font script="Tfng" typeface="Ebrima"/>
+      </a:majorFont>
+      <a:minorFont>
+        <a:latin typeface="Aptos" panose="02110004020202020204"/>
+        <a:ea typeface=""/>
+        <a:cs typeface=""/>
+        <a:font script="Jpan" typeface="游ゴシック"/>
+        <a:font script="Hang" typeface="맑은 고딕"/>
+        <a:font script="Hans" typeface="等线"/>
+        <a:font script="Hant" typeface="新細明體"/>
+        <a:font script="Arab" typeface="Arial"/>
+        <a:font script="Hebr" typeface="Arial"/>
+        <a:font script="Thai" typeface="Cordia New"/>
+        <a:font script="Ethi" typeface="Nyala"/>
+        <a:font script="Beng" typeface="Vrinda"/>
+        <a:font script="Gujr" typeface="Shruti"/>
+        <a:font script="Khmr" typeface="DaunPenh"/>
+        <a:font script="Knda" typeface="Tunga"/>
+        <a:font script="Guru" typeface="Raavi"/>
+        <a:font script="Cans" typeface="Euphemia"/>
+        <a:font script="Cher" typeface="Plantagenet Cherokee"/>
+        <a:font script="Yiii" typeface="Microsoft Yi Baiti"/>
+        <a:font script="Tibt" typeface="Microsoft Himalaya"/>
+        <a:font script="Thaa" typeface="MV Boli"/>
+        <a:font script="Deva" typeface="Mangal"/>
+        <a:font script="Telu" typeface="Gautami"/>
+        <a:font script="Taml" typeface="Latha"/>
+        <a:font script="Syrc" typeface="Estrangelo Edessa"/>
+        <a:font script="Orya" typeface="Kalinga"/>
+        <a:font script="Mlym" typeface="Kartika"/>
+        <a:font script="Laoo" typeface="DokChampa"/>
+        <a:font script="Sinh" typeface="Iskoola Pota"/>
+        <a:font script="Mong" typeface="Mongolian Baiti"/>
+        <a:font script="Viet" typeface="Arial"/>
+        <a:font script="Uigh" typeface="Microsoft Uighur"/>
+        <a:font script="Geor" typeface="Sylfaen"/>
+        <a:font script="Armn" typeface="Arial"/>
+        <a:font script="Bugi" typeface="Leelawadee UI"/>
+        <a:font script="Bopo" typeface="Microsoft JhengHei"/>
+        <a:font script="Java" typeface="Javanese Text"/>
+        <a:font script="Lisu" typeface="Segoe UI"/>
+        <a:font script="Mymr" typeface="Myanmar Text"/>
+        <a:font script="Nkoo" typeface="Ebrima"/>
+        <a:font script="Olck" typeface="Nirmala UI"/>
+        <a:font script="Osma" typeface="Ebrima"/>
+        <a:font script="Phag" typeface="Phagspa"/>
+        <a:font script="Syrn" typeface="Estrangelo Edessa"/>
+        <a:font script="Syrj" typeface="Estrangelo Edessa"/>
+        <a:font script="Syre" typeface="Estrangelo Edessa"/>
+        <a:font script="Sora" typeface="Nirmala UI"/>
+        <a:font script="Tale" typeface="Microsoft Tai Le"/>
+        <a:font script="Talu" typeface="Microsoft New Tai Lue"/>
+        <a:font script="Tfng" typeface="Ebrima"/>
+      </a:minorFont>
+    </a:fontScheme>
+    <a:fmtScheme name="Office">
+      <a:fillStyleLst>
+        <a:solidFill>
+          <a:schemeClr val="phClr"/>
+        </a:solidFill>
+        <a:gradFill rotWithShape="1">
+          <a:gsLst>
+            <a:gs pos="0">
+              <a:schemeClr val="phClr">
+                <a:lumMod val="110000"/>
+                <a:satMod val="105000"/>
+                <a:tint val="67000"/>
+              </a:schemeClr>
+            </a:gs>
+            <a:gs pos="50000">
+              <a:schemeClr val="phClr">
+                <a:lumMod val="105000"/>
+                <a:satMod val="103000"/>
+                <a:tint val="73000"/>
+              </a:schemeClr>
+            </a:gs>
+            <a:gs pos="100000">
+              <a:schemeClr val="phClr">
+                <a:lumMod val="105000"/>
+                <a:satMod val="109000"/>
+                <a:tint val="81000"/>
+              </a:schemeClr>
+            </a:gs>
+          </a:gsLst>
+          <a:lin ang="5400000" scaled="0"/>
+        </a:gradFill>
+        <a:gradFill rotWithShape="1">
+          <a:gsLst>
+            <a:gs pos="0">
+              <a:schemeClr val="phClr">
+                <a:satMod val="103000"/>
+                <a:lumMod val="102000"/>
+                <a:tint val="94000"/>
+              </a:schemeClr>
+            </a:gs>
+            <a:gs pos="50000">
+              <a:schemeClr val="phClr">
+                <a:satMod val="110000"/>
+                <a:lumMod val="100000"/>
+                <a:shade val="100000"/>
+              </a:schemeClr>
+            </a:gs>
+            <a:gs pos="100000">
+              <a:schemeClr val="phClr">
+                <a:lumMod val="99000"/>
+                <a:satMod val="120000"/>
+                <a:shade val="78000"/>
+              </a:schemeClr>
+            </a:gs>
+          </a:gsLst>
+          <a:lin ang="5400000" scaled="0"/>
+        </a:gradFill>
+      </a:fillStyleLst>
+      <a:lnStyleLst>
+        <a:ln w="12700" cap="flat" cmpd="sng" algn="ctr">
+          <a:solidFill>
+            <a:schemeClr val="phClr"/>
+          </a:solidFill>
+          <a:prstDash val="solid"/>
+          <a:miter lim="800000"/>
+        </a:ln>
+        <a:ln w="19050" cap="flat" cmpd="sng" algn="ctr">
+          <a:solidFill>
+            <a:schemeClr val="phClr"/>
+          </a:solidFill>
+          <a:prstDash val="solid"/>
+          <a:miter lim="800000"/>
+        </a:ln>
+        <a:ln w="25400" cap="flat" cmpd="sng" algn="ctr">
+          <a:solidFill>
+            <a:schemeClr val="phClr"/>
+          </a:solidFill>
+          <a:prstDash val="solid"/>
+          <a:miter lim="800000"/>
+        </a:ln>
+      </a:lnStyleLst>
+      <a:effectStyleLst>
+        <a:effectStyle>
+          <a:effectLst/>
+        </a:effectStyle>
+        <a:effectStyle>
+          <a:effectLst/>
+        </a:effectStyle>
+        <a:effectStyle>
+          <a:effectLst>
+            <a:outerShdw blurRad="57150" dist="19050" dir="5400000" algn="ctr" rotWithShape="0">
+              <a:srgbClr val="000000">
+                <a:alpha val="63000"/>
+              </a:srgbClr>
+            </a:outerShdw>
+          </a:effectLst>
+        </a:effectStyle>
+      </a:effectStyleLst>
+      <a:bgFillStyleLst>
+        <a:solidFill>
+          <a:schemeClr val="phClr"/>
+        </a:solidFill>
+        <a:solidFill>
+          <a:schemeClr val="phClr">
+            <a:tint val="95000"/>
+            <a:satMod val="170000"/>
+          </a:schemeClr>
+        </a:solidFill>
+        <a:gradFill rotWithShape="1">
+          <a:gsLst>
+            <a:gs pos="0">
+              <a:schemeClr val="phClr">
+                <a:tint val="93000"/>
+                <a:satMod val="150000"/>
+                <a:shade val="98000"/>
+                <a:lumMod val="102000"/>
+              </a:schemeClr>
+            </a:gs>
+            <a:gs pos="50000">
+              <a:schemeClr val="phClr">
+                <a:tint val="98000"/>
+                <a:satMod val="130000"/>
+                <a:shade val="90000"/>
+                <a:lumMod val="103000"/>
+              </a:schemeClr>
+            </a:gs>
+            <a:gs pos="100000">
+              <a:schemeClr val="phClr">
+                <a:shade val="63000"/>
+                <a:satMod val="120000"/>
+              </a:schemeClr>
+            </a:gs>
+          </a:gsLst>
+          <a:lin ang="5400000" scaled="0"/>
+        </a:gradFill>
+      </a:bgFillStyleLst>
+    </a:fmtScheme>
+  </a:themeElements>
+  <a:objectDefaults>
+    <a:lnDef>
+      <a:spPr/>
+      <a:bodyPr/>
+      <a:lstStyle/>
+      <a:style>
+        <a:lnRef idx="2">
+          <a:schemeClr val="accent1"/>
+        </a:lnRef>
+        <a:fillRef idx="0">
+          <a:schemeClr val="accent1"/>
+        </a:fillRef>
+        <a:effectRef idx="1">
+          <a:schemeClr val="accent1"/>
+        </a:effectRef>
+        <a:fontRef idx="minor">
+          <a:schemeClr val="tx1"/>
+        </a:fontRef>
+      </a:style>
+    </a:lnDef>
+  </a:objectDefaults>
+  <a:extraClrSchemeLst/>
+  <a:extLst>
+    <a:ext uri="{05A4C25C-085E-4340-85A3-A5531E510DB2}">
+      <thm15:themeFamily xmlns:thm15="http://schemas.microsoft.com/office/thememl/2012/main" name="Office Theme" id="{2E142A2C-CD16-42D6-873A-C26D2A0506FA}" vid="{1BDDFF52-6CD6-40A5-AB3C-68EB2F1E4D0A}"/>
+    </a:ext>
+  </a:extLst>
+</a:theme>
 </file>
</xml_diff>